<commit_message>
checkpoint: run artifacts before prompt-optimizer
Co-Authored-By: Claude Opus 4.8 <noreply@anthropic.com>
</commit_message>
<xml_diff>
--- a/upwork-runs/ai-chatbot-for-customer-support/proposal/deck.pptx
+++ b/upwork-runs/ai-chatbot-for-customer-support/proposal/deck.pptx
@@ -5,17 +5,16 @@
     <p:sldMasterId id="2147483648" r:id="rId1"/>
   </p:sldMasterIdLst>
   <p:sldIdLst>
-    <p:sldId id="256" r:id="rId7"/>
-    <p:sldId id="257" r:id="rId8"/>
-    <p:sldId id="258" r:id="rId9"/>
-    <p:sldId id="259" r:id="rId10"/>
-    <p:sldId id="260" r:id="rId11"/>
-    <p:sldId id="261" r:id="rId12"/>
-    <p:sldId id="262" r:id="rId13"/>
-    <p:sldId id="263" r:id="rId14"/>
-    <p:sldId id="264" r:id="rId15"/>
+    <p:sldId id="256" r:id="rId2"/>
+    <p:sldId id="257" r:id="rId3"/>
+    <p:sldId id="258" r:id="rId4"/>
+    <p:sldId id="259" r:id="rId5"/>
+    <p:sldId id="260" r:id="rId6"/>
+    <p:sldId id="261" r:id="rId7"/>
+    <p:sldId id="263" r:id="rId8"/>
+    <p:sldId id="264" r:id="rId9"/>
   </p:sldIdLst>
-  <p:sldSz cx="12191695" cy="6858000" type="screen4x3"/>
+  <p:sldSz cx="12192000" cy="6858000"/>
   <p:notesSz cx="6858000" cy="9144000"/>
   <p:defaultTextStyle>
     <a:defPPr>
@@ -112,6 +111,22 @@
       </a:defRPr>
     </a:lvl9pPr>
   </p:defaultTextStyle>
+  <p:extLst>
+    <p:ext uri="{EFAFB233-063F-42B5-8137-9DF3F51BA10A}">
+      <p15:sldGuideLst xmlns:p15="http://schemas.microsoft.com/office/powerpoint/2012/main">
+        <p15:guide id="1" orient="horz" pos="2160">
+          <p15:clr>
+            <a:srgbClr val="A4A3A4"/>
+          </p15:clr>
+        </p15:guide>
+        <p15:guide id="2" pos="2880">
+          <p15:clr>
+            <a:srgbClr val="A4A3A4"/>
+          </p15:clr>
+        </p15:guide>
+      </p15:sldGuideLst>
+    </p:ext>
+  </p:extLst>
 </p:presentation>
 </file>
 
@@ -153,10 +168,9 @@
           <a:lstStyle/>
           <a:p>
             <a:r>
-              <a:rPr lang="en-US" smtClean="0"/>
+              <a:rPr lang="en-US"/>
               <a:t>Click to edit Master title style</a:t>
             </a:r>
-            <a:endParaRPr lang="en-US"/>
           </a:p>
         </p:txBody>
       </p:sp>
@@ -272,10 +286,9 @@
           </a:lstStyle>
           <a:p>
             <a:r>
-              <a:rPr lang="en-US" smtClean="0"/>
+              <a:rPr lang="en-US"/>
               <a:t>Click to edit Master subtitle style</a:t>
             </a:r>
-            <a:endParaRPr lang="en-US"/>
           </a:p>
         </p:txBody>
       </p:sp>
@@ -296,7 +309,7 @@
           <a:p>
             <a:fld id="{5BCAD085-E8A6-8845-BD4E-CB4CCA059FC4}" type="datetimeFigureOut">
               <a:rPr lang="en-US" smtClean="0"/>
-              <a:t>1/27/13</a:t>
+              <a:t>6/18/26</a:t>
             </a:fld>
             <a:endParaRPr lang="en-US"/>
           </a:p>
@@ -390,10 +403,9 @@
           <a:lstStyle/>
           <a:p>
             <a:r>
-              <a:rPr lang="en-US" smtClean="0"/>
+              <a:rPr lang="en-US"/>
               <a:t>Click to edit Master title style</a:t>
             </a:r>
-            <a:endParaRPr lang="en-US"/>
           </a:p>
         </p:txBody>
       </p:sp>
@@ -414,38 +426,37 @@
           <a:p>
             <a:pPr lvl="0"/>
             <a:r>
-              <a:rPr lang="en-US" smtClean="0"/>
+              <a:rPr lang="en-US"/>
               <a:t>Click to edit Master text styles</a:t>
             </a:r>
           </a:p>
           <a:p>
             <a:pPr lvl="1"/>
             <a:r>
-              <a:rPr lang="en-US" smtClean="0"/>
+              <a:rPr lang="en-US"/>
               <a:t>Second level</a:t>
             </a:r>
           </a:p>
           <a:p>
             <a:pPr lvl="2"/>
             <a:r>
-              <a:rPr lang="en-US" smtClean="0"/>
+              <a:rPr lang="en-US"/>
               <a:t>Third level</a:t>
             </a:r>
           </a:p>
           <a:p>
             <a:pPr lvl="3"/>
             <a:r>
-              <a:rPr lang="en-US" smtClean="0"/>
+              <a:rPr lang="en-US"/>
               <a:t>Fourth level</a:t>
             </a:r>
           </a:p>
           <a:p>
             <a:pPr lvl="4"/>
             <a:r>
-              <a:rPr lang="en-US" smtClean="0"/>
+              <a:rPr lang="en-US"/>
               <a:t>Fifth level</a:t>
             </a:r>
-            <a:endParaRPr lang="en-US"/>
           </a:p>
         </p:txBody>
       </p:sp>
@@ -466,7 +477,7 @@
           <a:p>
             <a:fld id="{5BCAD085-E8A6-8845-BD4E-CB4CCA059FC4}" type="datetimeFigureOut">
               <a:rPr lang="en-US" smtClean="0"/>
-              <a:t>1/27/13</a:t>
+              <a:t>6/18/26</a:t>
             </a:fld>
             <a:endParaRPr lang="en-US"/>
           </a:p>
@@ -565,10 +576,9 @@
           <a:lstStyle/>
           <a:p>
             <a:r>
-              <a:rPr lang="en-US" smtClean="0"/>
+              <a:rPr lang="en-US"/>
               <a:t>Click to edit Master title style</a:t>
             </a:r>
-            <a:endParaRPr lang="en-US"/>
           </a:p>
         </p:txBody>
       </p:sp>
@@ -594,38 +604,37 @@
           <a:p>
             <a:pPr lvl="0"/>
             <a:r>
-              <a:rPr lang="en-US" smtClean="0"/>
+              <a:rPr lang="en-US"/>
               <a:t>Click to edit Master text styles</a:t>
             </a:r>
           </a:p>
           <a:p>
             <a:pPr lvl="1"/>
             <a:r>
-              <a:rPr lang="en-US" smtClean="0"/>
+              <a:rPr lang="en-US"/>
               <a:t>Second level</a:t>
             </a:r>
           </a:p>
           <a:p>
             <a:pPr lvl="2"/>
             <a:r>
-              <a:rPr lang="en-US" smtClean="0"/>
+              <a:rPr lang="en-US"/>
               <a:t>Third level</a:t>
             </a:r>
           </a:p>
           <a:p>
             <a:pPr lvl="3"/>
             <a:r>
-              <a:rPr lang="en-US" smtClean="0"/>
+              <a:rPr lang="en-US"/>
               <a:t>Fourth level</a:t>
             </a:r>
           </a:p>
           <a:p>
             <a:pPr lvl="4"/>
             <a:r>
-              <a:rPr lang="en-US" smtClean="0"/>
+              <a:rPr lang="en-US"/>
               <a:t>Fifth level</a:t>
             </a:r>
-            <a:endParaRPr lang="en-US"/>
           </a:p>
         </p:txBody>
       </p:sp>
@@ -646,7 +655,7 @@
           <a:p>
             <a:fld id="{5BCAD085-E8A6-8845-BD4E-CB4CCA059FC4}" type="datetimeFigureOut">
               <a:rPr lang="en-US" smtClean="0"/>
-              <a:t>1/27/13</a:t>
+              <a:t>6/18/26</a:t>
             </a:fld>
             <a:endParaRPr lang="en-US"/>
           </a:p>
@@ -740,10 +749,9 @@
           <a:lstStyle/>
           <a:p>
             <a:r>
-              <a:rPr lang="en-US" smtClean="0"/>
+              <a:rPr lang="en-US"/>
               <a:t>Click to edit Master title style</a:t>
             </a:r>
-            <a:endParaRPr lang="en-US"/>
           </a:p>
         </p:txBody>
       </p:sp>
@@ -764,38 +772,37 @@
           <a:p>
             <a:pPr lvl="0"/>
             <a:r>
-              <a:rPr lang="en-US" smtClean="0"/>
+              <a:rPr lang="en-US"/>
               <a:t>Click to edit Master text styles</a:t>
             </a:r>
           </a:p>
           <a:p>
             <a:pPr lvl="1"/>
             <a:r>
-              <a:rPr lang="en-US" smtClean="0"/>
+              <a:rPr lang="en-US"/>
               <a:t>Second level</a:t>
             </a:r>
           </a:p>
           <a:p>
             <a:pPr lvl="2"/>
             <a:r>
-              <a:rPr lang="en-US" smtClean="0"/>
+              <a:rPr lang="en-US"/>
               <a:t>Third level</a:t>
             </a:r>
           </a:p>
           <a:p>
             <a:pPr lvl="3"/>
             <a:r>
-              <a:rPr lang="en-US" smtClean="0"/>
+              <a:rPr lang="en-US"/>
               <a:t>Fourth level</a:t>
             </a:r>
           </a:p>
           <a:p>
             <a:pPr lvl="4"/>
             <a:r>
-              <a:rPr lang="en-US" smtClean="0"/>
+              <a:rPr lang="en-US"/>
               <a:t>Fifth level</a:t>
             </a:r>
-            <a:endParaRPr lang="en-US"/>
           </a:p>
         </p:txBody>
       </p:sp>
@@ -816,7 +823,7 @@
           <a:p>
             <a:fld id="{5BCAD085-E8A6-8845-BD4E-CB4CCA059FC4}" type="datetimeFigureOut">
               <a:rPr lang="en-US" smtClean="0"/>
-              <a:t>1/27/13</a:t>
+              <a:t>6/18/26</a:t>
             </a:fld>
             <a:endParaRPr lang="en-US"/>
           </a:p>
@@ -919,10 +926,9 @@
           </a:lstStyle>
           <a:p>
             <a:r>
-              <a:rPr lang="en-US" smtClean="0"/>
+              <a:rPr lang="en-US"/>
               <a:t>Click to edit Master title style</a:t>
             </a:r>
-            <a:endParaRPr lang="en-US"/>
           </a:p>
         </p:txBody>
       </p:sp>
@@ -1039,7 +1045,7 @@
           <a:p>
             <a:pPr lvl="0"/>
             <a:r>
-              <a:rPr lang="en-US" smtClean="0"/>
+              <a:rPr lang="en-US"/>
               <a:t>Click to edit Master text styles</a:t>
             </a:r>
           </a:p>
@@ -1062,7 +1068,7 @@
           <a:p>
             <a:fld id="{5BCAD085-E8A6-8845-BD4E-CB4CCA059FC4}" type="datetimeFigureOut">
               <a:rPr lang="en-US" smtClean="0"/>
-              <a:t>1/27/13</a:t>
+              <a:t>6/18/26</a:t>
             </a:fld>
             <a:endParaRPr lang="en-US"/>
           </a:p>
@@ -1156,10 +1162,9 @@
           <a:lstStyle/>
           <a:p>
             <a:r>
-              <a:rPr lang="en-US" smtClean="0"/>
+              <a:rPr lang="en-US"/>
               <a:t>Click to edit Master title style</a:t>
             </a:r>
-            <a:endParaRPr lang="en-US"/>
           </a:p>
         </p:txBody>
       </p:sp>
@@ -1213,38 +1218,37 @@
           <a:p>
             <a:pPr lvl="0"/>
             <a:r>
-              <a:rPr lang="en-US" smtClean="0"/>
+              <a:rPr lang="en-US"/>
               <a:t>Click to edit Master text styles</a:t>
             </a:r>
           </a:p>
           <a:p>
             <a:pPr lvl="1"/>
             <a:r>
-              <a:rPr lang="en-US" smtClean="0"/>
+              <a:rPr lang="en-US"/>
               <a:t>Second level</a:t>
             </a:r>
           </a:p>
           <a:p>
             <a:pPr lvl="2"/>
             <a:r>
-              <a:rPr lang="en-US" smtClean="0"/>
+              <a:rPr lang="en-US"/>
               <a:t>Third level</a:t>
             </a:r>
           </a:p>
           <a:p>
             <a:pPr lvl="3"/>
             <a:r>
-              <a:rPr lang="en-US" smtClean="0"/>
+              <a:rPr lang="en-US"/>
               <a:t>Fourth level</a:t>
             </a:r>
           </a:p>
           <a:p>
             <a:pPr lvl="4"/>
             <a:r>
-              <a:rPr lang="en-US" smtClean="0"/>
+              <a:rPr lang="en-US"/>
               <a:t>Fifth level</a:t>
             </a:r>
-            <a:endParaRPr lang="en-US"/>
           </a:p>
         </p:txBody>
       </p:sp>
@@ -1298,38 +1302,37 @@
           <a:p>
             <a:pPr lvl="0"/>
             <a:r>
-              <a:rPr lang="en-US" smtClean="0"/>
+              <a:rPr lang="en-US"/>
               <a:t>Click to edit Master text styles</a:t>
             </a:r>
           </a:p>
           <a:p>
             <a:pPr lvl="1"/>
             <a:r>
-              <a:rPr lang="en-US" smtClean="0"/>
+              <a:rPr lang="en-US"/>
               <a:t>Second level</a:t>
             </a:r>
           </a:p>
           <a:p>
             <a:pPr lvl="2"/>
             <a:r>
-              <a:rPr lang="en-US" smtClean="0"/>
+              <a:rPr lang="en-US"/>
               <a:t>Third level</a:t>
             </a:r>
           </a:p>
           <a:p>
             <a:pPr lvl="3"/>
             <a:r>
-              <a:rPr lang="en-US" smtClean="0"/>
+              <a:rPr lang="en-US"/>
               <a:t>Fourth level</a:t>
             </a:r>
           </a:p>
           <a:p>
             <a:pPr lvl="4"/>
             <a:r>
-              <a:rPr lang="en-US" smtClean="0"/>
+              <a:rPr lang="en-US"/>
               <a:t>Fifth level</a:t>
             </a:r>
-            <a:endParaRPr lang="en-US"/>
           </a:p>
         </p:txBody>
       </p:sp>
@@ -1350,7 +1353,7 @@
           <a:p>
             <a:fld id="{5BCAD085-E8A6-8845-BD4E-CB4CCA059FC4}" type="datetimeFigureOut">
               <a:rPr lang="en-US" smtClean="0"/>
-              <a:t>1/27/13</a:t>
+              <a:t>6/18/26</a:t>
             </a:fld>
             <a:endParaRPr lang="en-US"/>
           </a:p>
@@ -1448,10 +1451,9 @@
           </a:lstStyle>
           <a:p>
             <a:r>
-              <a:rPr lang="en-US" smtClean="0"/>
+              <a:rPr lang="en-US"/>
               <a:t>Click to edit Master title style</a:t>
             </a:r>
-            <a:endParaRPr lang="en-US"/>
           </a:p>
         </p:txBody>
       </p:sp>
@@ -1514,7 +1516,7 @@
           <a:p>
             <a:pPr lvl="0"/>
             <a:r>
-              <a:rPr lang="en-US" smtClean="0"/>
+              <a:rPr lang="en-US"/>
               <a:t>Click to edit Master text styles</a:t>
             </a:r>
           </a:p>
@@ -1570,38 +1572,37 @@
           <a:p>
             <a:pPr lvl="0"/>
             <a:r>
-              <a:rPr lang="en-US" smtClean="0"/>
+              <a:rPr lang="en-US"/>
               <a:t>Click to edit Master text styles</a:t>
             </a:r>
           </a:p>
           <a:p>
             <a:pPr lvl="1"/>
             <a:r>
-              <a:rPr lang="en-US" smtClean="0"/>
+              <a:rPr lang="en-US"/>
               <a:t>Second level</a:t>
             </a:r>
           </a:p>
           <a:p>
             <a:pPr lvl="2"/>
             <a:r>
-              <a:rPr lang="en-US" smtClean="0"/>
+              <a:rPr lang="en-US"/>
               <a:t>Third level</a:t>
             </a:r>
           </a:p>
           <a:p>
             <a:pPr lvl="3"/>
             <a:r>
-              <a:rPr lang="en-US" smtClean="0"/>
+              <a:rPr lang="en-US"/>
               <a:t>Fourth level</a:t>
             </a:r>
           </a:p>
           <a:p>
             <a:pPr lvl="4"/>
             <a:r>
-              <a:rPr lang="en-US" smtClean="0"/>
+              <a:rPr lang="en-US"/>
               <a:t>Fifth level</a:t>
             </a:r>
-            <a:endParaRPr lang="en-US"/>
           </a:p>
         </p:txBody>
       </p:sp>
@@ -1664,7 +1665,7 @@
           <a:p>
             <a:pPr lvl="0"/>
             <a:r>
-              <a:rPr lang="en-US" smtClean="0"/>
+              <a:rPr lang="en-US"/>
               <a:t>Click to edit Master text styles</a:t>
             </a:r>
           </a:p>
@@ -1720,38 +1721,37 @@
           <a:p>
             <a:pPr lvl="0"/>
             <a:r>
-              <a:rPr lang="en-US" smtClean="0"/>
+              <a:rPr lang="en-US"/>
               <a:t>Click to edit Master text styles</a:t>
             </a:r>
           </a:p>
           <a:p>
             <a:pPr lvl="1"/>
             <a:r>
-              <a:rPr lang="en-US" smtClean="0"/>
+              <a:rPr lang="en-US"/>
               <a:t>Second level</a:t>
             </a:r>
           </a:p>
           <a:p>
             <a:pPr lvl="2"/>
             <a:r>
-              <a:rPr lang="en-US" smtClean="0"/>
+              <a:rPr lang="en-US"/>
               <a:t>Third level</a:t>
             </a:r>
           </a:p>
           <a:p>
             <a:pPr lvl="3"/>
             <a:r>
-              <a:rPr lang="en-US" smtClean="0"/>
+              <a:rPr lang="en-US"/>
               <a:t>Fourth level</a:t>
             </a:r>
           </a:p>
           <a:p>
             <a:pPr lvl="4"/>
             <a:r>
-              <a:rPr lang="en-US" smtClean="0"/>
+              <a:rPr lang="en-US"/>
               <a:t>Fifth level</a:t>
             </a:r>
-            <a:endParaRPr lang="en-US"/>
           </a:p>
         </p:txBody>
       </p:sp>
@@ -1772,7 +1772,7 @@
           <a:p>
             <a:fld id="{5BCAD085-E8A6-8845-BD4E-CB4CCA059FC4}" type="datetimeFigureOut">
               <a:rPr lang="en-US" smtClean="0"/>
-              <a:t>1/27/13</a:t>
+              <a:t>6/18/26</a:t>
             </a:fld>
             <a:endParaRPr lang="en-US"/>
           </a:p>
@@ -1866,10 +1866,9 @@
           <a:lstStyle/>
           <a:p>
             <a:r>
-              <a:rPr lang="en-US" smtClean="0"/>
+              <a:rPr lang="en-US"/>
               <a:t>Click to edit Master title style</a:t>
             </a:r>
-            <a:endParaRPr lang="en-US"/>
           </a:p>
         </p:txBody>
       </p:sp>
@@ -1890,7 +1889,7 @@
           <a:p>
             <a:fld id="{5BCAD085-E8A6-8845-BD4E-CB4CCA059FC4}" type="datetimeFigureOut">
               <a:rPr lang="en-US" smtClean="0"/>
-              <a:t>1/27/13</a:t>
+              <a:t>6/18/26</a:t>
             </a:fld>
             <a:endParaRPr lang="en-US"/>
           </a:p>
@@ -1985,7 +1984,7 @@
           <a:p>
             <a:fld id="{5BCAD085-E8A6-8845-BD4E-CB4CCA059FC4}" type="datetimeFigureOut">
               <a:rPr lang="en-US" smtClean="0"/>
-              <a:t>1/27/13</a:t>
+              <a:t>6/18/26</a:t>
             </a:fld>
             <a:endParaRPr lang="en-US"/>
           </a:p>
@@ -2088,10 +2087,9 @@
           </a:lstStyle>
           <a:p>
             <a:r>
-              <a:rPr lang="en-US" smtClean="0"/>
+              <a:rPr lang="en-US"/>
               <a:t>Click to edit Master title style</a:t>
             </a:r>
-            <a:endParaRPr lang="en-US"/>
           </a:p>
         </p:txBody>
       </p:sp>
@@ -2145,38 +2143,37 @@
           <a:p>
             <a:pPr lvl="0"/>
             <a:r>
-              <a:rPr lang="en-US" smtClean="0"/>
+              <a:rPr lang="en-US"/>
               <a:t>Click to edit Master text styles</a:t>
             </a:r>
           </a:p>
           <a:p>
             <a:pPr lvl="1"/>
             <a:r>
-              <a:rPr lang="en-US" smtClean="0"/>
+              <a:rPr lang="en-US"/>
               <a:t>Second level</a:t>
             </a:r>
           </a:p>
           <a:p>
             <a:pPr lvl="2"/>
             <a:r>
-              <a:rPr lang="en-US" smtClean="0"/>
+              <a:rPr lang="en-US"/>
               <a:t>Third level</a:t>
             </a:r>
           </a:p>
           <a:p>
             <a:pPr lvl="3"/>
             <a:r>
-              <a:rPr lang="en-US" smtClean="0"/>
+              <a:rPr lang="en-US"/>
               <a:t>Fourth level</a:t>
             </a:r>
           </a:p>
           <a:p>
             <a:pPr lvl="4"/>
             <a:r>
-              <a:rPr lang="en-US" smtClean="0"/>
+              <a:rPr lang="en-US"/>
               <a:t>Fifth level</a:t>
             </a:r>
-            <a:endParaRPr lang="en-US"/>
           </a:p>
         </p:txBody>
       </p:sp>
@@ -2239,7 +2236,7 @@
           <a:p>
             <a:pPr lvl="0"/>
             <a:r>
-              <a:rPr lang="en-US" smtClean="0"/>
+              <a:rPr lang="en-US"/>
               <a:t>Click to edit Master text styles</a:t>
             </a:r>
           </a:p>
@@ -2262,7 +2259,7 @@
           <a:p>
             <a:fld id="{5BCAD085-E8A6-8845-BD4E-CB4CCA059FC4}" type="datetimeFigureOut">
               <a:rPr lang="en-US" smtClean="0"/>
-              <a:t>1/27/13</a:t>
+              <a:t>6/18/26</a:t>
             </a:fld>
             <a:endParaRPr lang="en-US"/>
           </a:p>
@@ -2365,10 +2362,9 @@
           </a:lstStyle>
           <a:p>
             <a:r>
-              <a:rPr lang="en-US" smtClean="0"/>
+              <a:rPr lang="en-US"/>
               <a:t>Click to edit Master title style</a:t>
             </a:r>
-            <a:endParaRPr lang="en-US"/>
           </a:p>
         </p:txBody>
       </p:sp>
@@ -2492,7 +2488,7 @@
           <a:p>
             <a:pPr lvl="0"/>
             <a:r>
-              <a:rPr lang="en-US" smtClean="0"/>
+              <a:rPr lang="en-US"/>
               <a:t>Click to edit Master text styles</a:t>
             </a:r>
           </a:p>
@@ -2515,7 +2511,7 @@
           <a:p>
             <a:fld id="{5BCAD085-E8A6-8845-BD4E-CB4CCA059FC4}" type="datetimeFigureOut">
               <a:rPr lang="en-US" smtClean="0"/>
-              <a:t>1/27/13</a:t>
+              <a:t>6/18/26</a:t>
             </a:fld>
             <a:endParaRPr lang="en-US"/>
           </a:p>
@@ -2624,10 +2620,9 @@
           <a:lstStyle/>
           <a:p>
             <a:r>
-              <a:rPr lang="en-US" smtClean="0"/>
+              <a:rPr lang="en-US"/>
               <a:t>Click to edit Master title style</a:t>
             </a:r>
-            <a:endParaRPr lang="en-US"/>
           </a:p>
         </p:txBody>
       </p:sp>
@@ -2658,38 +2653,37 @@
           <a:p>
             <a:pPr lvl="0"/>
             <a:r>
-              <a:rPr lang="en-US" smtClean="0"/>
+              <a:rPr lang="en-US"/>
               <a:t>Click to edit Master text styles</a:t>
             </a:r>
           </a:p>
           <a:p>
             <a:pPr lvl="1"/>
             <a:r>
-              <a:rPr lang="en-US" smtClean="0"/>
+              <a:rPr lang="en-US"/>
               <a:t>Second level</a:t>
             </a:r>
           </a:p>
           <a:p>
             <a:pPr lvl="2"/>
             <a:r>
-              <a:rPr lang="en-US" smtClean="0"/>
+              <a:rPr lang="en-US"/>
               <a:t>Third level</a:t>
             </a:r>
           </a:p>
           <a:p>
             <a:pPr lvl="3"/>
             <a:r>
-              <a:rPr lang="en-US" smtClean="0"/>
+              <a:rPr lang="en-US"/>
               <a:t>Fourth level</a:t>
             </a:r>
           </a:p>
           <a:p>
             <a:pPr lvl="4"/>
             <a:r>
-              <a:rPr lang="en-US" smtClean="0"/>
+              <a:rPr lang="en-US"/>
               <a:t>Fifth level</a:t>
             </a:r>
-            <a:endParaRPr lang="en-US"/>
           </a:p>
         </p:txBody>
       </p:sp>
@@ -2728,7 +2722,7 @@
           <a:p>
             <a:fld id="{5BCAD085-E8A6-8845-BD4E-CB4CCA059FC4}" type="datetimeFigureOut">
               <a:rPr lang="en-US" smtClean="0"/>
-              <a:t>1/27/13</a:t>
+              <a:t>6/18/26</a:t>
             </a:fld>
             <a:endParaRPr lang="en-US"/>
           </a:p>
@@ -3087,7 +3081,7 @@
 </file>
 
 <file path=ppt/slides/slide1.xml><?xml version="1.0" encoding="utf-8"?>
-<p:sld xmlns:a="http://schemas.openxmlformats.org/drawingml/2006/main" xmlns:p="http://schemas.openxmlformats.org/presentationml/2006/main" xmlns:r="http://schemas.openxmlformats.org/officeDocument/2006/relationships">
+<p:sld xmlns:a="http://schemas.openxmlformats.org/drawingml/2006/main" xmlns:r="http://schemas.openxmlformats.org/officeDocument/2006/relationships" xmlns:p="http://schemas.openxmlformats.org/presentationml/2006/main">
   <p:cSld>
     <p:spTree>
       <p:nvGrpSpPr>
@@ -3095,7 +3089,14 @@
         <p:cNvGrpSpPr/>
         <p:nvPr/>
       </p:nvGrpSpPr>
-      <p:grpSpPr/>
+      <p:grpSpPr>
+        <a:xfrm>
+          <a:off x="0" y="0"/>
+          <a:ext cx="0" cy="0"/>
+          <a:chOff x="0" y="0"/>
+          <a:chExt cx="0" cy="0"/>
+        </a:xfrm>
+      </p:grpSpPr>
       <p:sp>
         <p:nvSpPr>
           <p:cNvPr id="2" name="Rectangle 1"/>
@@ -3137,6 +3138,7 @@
           <a:lstStyle/>
           <a:p>
             <a:pPr algn="ctr"/>
+            <a:endParaRPr/>
           </a:p>
         </p:txBody>
       </p:sp>
@@ -3181,6 +3183,7 @@
           <a:lstStyle/>
           <a:p>
             <a:pPr algn="ctr"/>
+            <a:endParaRPr/>
           </a:p>
         </p:txBody>
       </p:sp>
@@ -3201,7 +3204,7 @@
           <a:noFill/>
         </p:spPr>
         <p:txBody>
-          <a:bodyPr wrap="square" lIns="0" rIns="0" tIns="0" bIns="0" anchor="t">
+          <a:bodyPr wrap="square" lIns="0" tIns="0" rIns="0" bIns="0" anchor="t">
             <a:spAutoFit/>
           </a:bodyPr>
           <a:lstStyle/>
@@ -3236,7 +3239,7 @@
           <a:noFill/>
         </p:spPr>
         <p:txBody>
-          <a:bodyPr wrap="square" lIns="0" rIns="0" tIns="0" bIns="0" anchor="t">
+          <a:bodyPr wrap="square" lIns="0" tIns="0" rIns="0" bIns="0" anchor="t">
             <a:spAutoFit/>
           </a:bodyPr>
           <a:lstStyle/>
@@ -3271,7 +3274,7 @@
           <a:noFill/>
         </p:spPr>
         <p:txBody>
-          <a:bodyPr wrap="square" lIns="0" rIns="0" tIns="0" bIns="0" anchor="t">
+          <a:bodyPr wrap="square" lIns="0" tIns="0" rIns="0" bIns="0" anchor="t">
             <a:spAutoFit/>
           </a:bodyPr>
           <a:lstStyle/>
@@ -3344,6 +3347,7 @@
           <a:lstStyle/>
           <a:p>
             <a:pPr algn="ctr"/>
+            <a:endParaRPr/>
           </a:p>
         </p:txBody>
       </p:sp>
@@ -3364,7 +3368,7 @@
           <a:noFill/>
         </p:spPr>
         <p:txBody>
-          <a:bodyPr wrap="square" lIns="0" rIns="0" tIns="0" bIns="0" anchor="t">
+          <a:bodyPr wrap="square" lIns="0" tIns="0" rIns="0" bIns="0" anchor="t">
             <a:spAutoFit/>
           </a:bodyPr>
           <a:lstStyle/>
@@ -3399,20 +3403,29 @@
           <a:noFill/>
         </p:spPr>
         <p:txBody>
-          <a:bodyPr wrap="square" lIns="0" rIns="0" tIns="0" bIns="0" anchor="t">
-            <a:spAutoFit/>
-          </a:bodyPr>
-          <a:lstStyle/>
-          <a:p>
-            <a:pPr algn="l"/>
-            <a:r>
-              <a:rPr sz="1200" b="0">
+          <a:bodyPr wrap="square" lIns="0" tIns="0" rIns="0" bIns="0" anchor="t">
+            <a:spAutoFit/>
+          </a:bodyPr>
+          <a:lstStyle/>
+          <a:p>
+            <a:pPr algn="l"/>
+            <a:r>
+              <a:rPr sz="1200" b="0" dirty="0" err="1">
                 <a:solidFill>
                   <a:srgbClr val="3799F8"/>
                 </a:solidFill>
                 <a:latin typeface="Inter"/>
               </a:rPr>
-              <a:t>michaelwegter.com/demos/ai-chatbot-for-customer-support/</a:t>
+              <a:t>michaelwegter.com</a:t>
+            </a:r>
+            <a:r>
+              <a:rPr sz="1200" b="0" dirty="0">
+                <a:solidFill>
+                  <a:srgbClr val="3799F8"/>
+                </a:solidFill>
+                <a:latin typeface="Inter"/>
+              </a:rPr>
+              <a:t>/demos/ai-chatbot-for-customer-support/</a:t>
             </a:r>
           </a:p>
         </p:txBody>
@@ -3434,7 +3447,7 @@
           <a:noFill/>
         </p:spPr>
         <p:txBody>
-          <a:bodyPr wrap="square" lIns="0" rIns="0" tIns="0" bIns="0" anchor="t">
+          <a:bodyPr wrap="square" lIns="0" tIns="0" rIns="0" bIns="0" anchor="t">
             <a:spAutoFit/>
           </a:bodyPr>
           <a:lstStyle/>
@@ -3469,7 +3482,7 @@
           <a:noFill/>
         </p:spPr>
         <p:txBody>
-          <a:bodyPr wrap="square" lIns="0" rIns="0" tIns="0" bIns="0" anchor="t">
+          <a:bodyPr wrap="square" lIns="0" tIns="0" rIns="0" bIns="0" anchor="t">
             <a:spAutoFit/>
           </a:bodyPr>
           <a:lstStyle/>
@@ -3504,7 +3517,7 @@
           <a:noFill/>
         </p:spPr>
         <p:txBody>
-          <a:bodyPr wrap="square" lIns="0" rIns="0" tIns="0" bIns="0" anchor="t">
+          <a:bodyPr wrap="square" lIns="0" tIns="0" rIns="0" bIns="0" anchor="t">
             <a:spAutoFit/>
           </a:bodyPr>
           <a:lstStyle/>
@@ -3531,7 +3544,7 @@
 </file>
 
 <file path=ppt/slides/slide2.xml><?xml version="1.0" encoding="utf-8"?>
-<p:sld xmlns:a="http://schemas.openxmlformats.org/drawingml/2006/main" xmlns:p="http://schemas.openxmlformats.org/presentationml/2006/main" xmlns:r="http://schemas.openxmlformats.org/officeDocument/2006/relationships">
+<p:sld xmlns:a="http://schemas.openxmlformats.org/drawingml/2006/main" xmlns:r="http://schemas.openxmlformats.org/officeDocument/2006/relationships" xmlns:p="http://schemas.openxmlformats.org/presentationml/2006/main">
   <p:cSld>
     <p:spTree>
       <p:nvGrpSpPr>
@@ -3539,7 +3552,14 @@
         <p:cNvGrpSpPr/>
         <p:nvPr/>
       </p:nvGrpSpPr>
-      <p:grpSpPr/>
+      <p:grpSpPr>
+        <a:xfrm>
+          <a:off x="0" y="0"/>
+          <a:ext cx="0" cy="0"/>
+          <a:chOff x="0" y="0"/>
+          <a:chExt cx="0" cy="0"/>
+        </a:xfrm>
+      </p:grpSpPr>
       <p:sp>
         <p:nvSpPr>
           <p:cNvPr id="2" name="Rectangle 1"/>
@@ -3581,6 +3601,7 @@
           <a:lstStyle/>
           <a:p>
             <a:pPr algn="ctr"/>
+            <a:endParaRPr/>
           </a:p>
         </p:txBody>
       </p:sp>
@@ -3601,7 +3622,7 @@
           <a:noFill/>
         </p:spPr>
         <p:txBody>
-          <a:bodyPr wrap="square" lIns="0" rIns="0" tIns="0" bIns="0" anchor="t">
+          <a:bodyPr wrap="square" lIns="0" tIns="0" rIns="0" bIns="0" anchor="t">
             <a:spAutoFit/>
           </a:bodyPr>
           <a:lstStyle/>
@@ -3636,7 +3657,7 @@
           <a:noFill/>
         </p:spPr>
         <p:txBody>
-          <a:bodyPr wrap="square" lIns="0" rIns="0" tIns="0" bIns="0" anchor="t">
+          <a:bodyPr wrap="square" lIns="0" tIns="0" rIns="0" bIns="0" anchor="t">
             <a:spAutoFit/>
           </a:bodyPr>
           <a:lstStyle/>
@@ -3697,6 +3718,7 @@
           <a:lstStyle/>
           <a:p>
             <a:pPr algn="ctr"/>
+            <a:endParaRPr/>
           </a:p>
         </p:txBody>
       </p:sp>
@@ -3717,7 +3739,7 @@
           <a:noFill/>
         </p:spPr>
         <p:txBody>
-          <a:bodyPr wrap="square" lIns="0" rIns="0" tIns="0" bIns="0" anchor="t">
+          <a:bodyPr wrap="square" lIns="0" tIns="0" rIns="0" bIns="0" anchor="t">
             <a:spAutoFit/>
           </a:bodyPr>
           <a:lstStyle/>
@@ -3752,7 +3774,7 @@
           <a:noFill/>
         </p:spPr>
         <p:txBody>
-          <a:bodyPr wrap="square" lIns="0" rIns="0" tIns="0" bIns="0" anchor="t">
+          <a:bodyPr wrap="square" lIns="0" tIns="0" rIns="0" bIns="0" anchor="t">
             <a:spAutoFit/>
           </a:bodyPr>
           <a:lstStyle/>
@@ -3813,6 +3835,7 @@
           <a:lstStyle/>
           <a:p>
             <a:pPr algn="ctr"/>
+            <a:endParaRPr/>
           </a:p>
         </p:txBody>
       </p:sp>
@@ -3833,7 +3856,7 @@
           <a:noFill/>
         </p:spPr>
         <p:txBody>
-          <a:bodyPr wrap="square" lIns="0" rIns="0" tIns="0" bIns="0" anchor="t">
+          <a:bodyPr wrap="square" lIns="0" tIns="0" rIns="0" bIns="0" anchor="t">
             <a:spAutoFit/>
           </a:bodyPr>
           <a:lstStyle/>
@@ -3868,7 +3891,7 @@
           <a:noFill/>
         </p:spPr>
         <p:txBody>
-          <a:bodyPr wrap="square" lIns="0" rIns="0" tIns="0" bIns="0" anchor="t">
+          <a:bodyPr wrap="square" lIns="0" tIns="0" rIns="0" bIns="0" anchor="t">
             <a:spAutoFit/>
           </a:bodyPr>
           <a:lstStyle/>
@@ -3929,6 +3952,7 @@
           <a:lstStyle/>
           <a:p>
             <a:pPr algn="ctr"/>
+            <a:endParaRPr/>
           </a:p>
         </p:txBody>
       </p:sp>
@@ -3949,7 +3973,7 @@
           <a:noFill/>
         </p:spPr>
         <p:txBody>
-          <a:bodyPr wrap="square" lIns="0" rIns="0" tIns="0" bIns="0" anchor="t">
+          <a:bodyPr wrap="square" lIns="0" tIns="0" rIns="0" bIns="0" anchor="t">
             <a:spAutoFit/>
           </a:bodyPr>
           <a:lstStyle/>
@@ -3984,7 +4008,7 @@
           <a:noFill/>
         </p:spPr>
         <p:txBody>
-          <a:bodyPr wrap="square" lIns="0" rIns="0" tIns="0" bIns="0" anchor="t">
+          <a:bodyPr wrap="square" lIns="0" tIns="0" rIns="0" bIns="0" anchor="t">
             <a:spAutoFit/>
           </a:bodyPr>
           <a:lstStyle/>
@@ -4045,6 +4069,7 @@
           <a:lstStyle/>
           <a:p>
             <a:pPr algn="ctr"/>
+            <a:endParaRPr/>
           </a:p>
         </p:txBody>
       </p:sp>
@@ -4065,7 +4090,7 @@
           <a:noFill/>
         </p:spPr>
         <p:txBody>
-          <a:bodyPr wrap="square" lIns="0" rIns="0" tIns="0" bIns="0" anchor="t">
+          <a:bodyPr wrap="square" lIns="0" tIns="0" rIns="0" bIns="0" anchor="t">
             <a:spAutoFit/>
           </a:bodyPr>
           <a:lstStyle/>
@@ -4100,7 +4125,7 @@
           <a:noFill/>
         </p:spPr>
         <p:txBody>
-          <a:bodyPr wrap="square" lIns="0" rIns="0" tIns="0" bIns="0" anchor="t">
+          <a:bodyPr wrap="square" lIns="0" tIns="0" rIns="0" bIns="0" anchor="t">
             <a:spAutoFit/>
           </a:bodyPr>
           <a:lstStyle/>
@@ -4135,7 +4160,7 @@
           <a:noFill/>
         </p:spPr>
         <p:txBody>
-          <a:bodyPr wrap="square" lIns="0" rIns="0" tIns="0" bIns="0" anchor="t">
+          <a:bodyPr wrap="square" lIns="0" tIns="0" rIns="0" bIns="0" anchor="t">
             <a:spAutoFit/>
           </a:bodyPr>
           <a:lstStyle/>
@@ -4170,7 +4195,7 @@
           <a:noFill/>
         </p:spPr>
         <p:txBody>
-          <a:bodyPr wrap="square" lIns="0" rIns="0" tIns="0" bIns="0" anchor="t">
+          <a:bodyPr wrap="square" lIns="0" tIns="0" rIns="0" bIns="0" anchor="t">
             <a:spAutoFit/>
           </a:bodyPr>
           <a:lstStyle/>
@@ -4197,7 +4222,7 @@
 </file>
 
 <file path=ppt/slides/slide3.xml><?xml version="1.0" encoding="utf-8"?>
-<p:sld xmlns:a="http://schemas.openxmlformats.org/drawingml/2006/main" xmlns:p="http://schemas.openxmlformats.org/presentationml/2006/main" xmlns:r="http://schemas.openxmlformats.org/officeDocument/2006/relationships">
+<p:sld xmlns:a="http://schemas.openxmlformats.org/drawingml/2006/main" xmlns:r="http://schemas.openxmlformats.org/officeDocument/2006/relationships" xmlns:p="http://schemas.openxmlformats.org/presentationml/2006/main">
   <p:cSld>
     <p:spTree>
       <p:nvGrpSpPr>
@@ -4205,7 +4230,14 @@
         <p:cNvGrpSpPr/>
         <p:nvPr/>
       </p:nvGrpSpPr>
-      <p:grpSpPr/>
+      <p:grpSpPr>
+        <a:xfrm>
+          <a:off x="0" y="0"/>
+          <a:ext cx="0" cy="0"/>
+          <a:chOff x="0" y="0"/>
+          <a:chExt cx="0" cy="0"/>
+        </a:xfrm>
+      </p:grpSpPr>
       <p:sp>
         <p:nvSpPr>
           <p:cNvPr id="2" name="Rectangle 1"/>
@@ -4247,6 +4279,7 @@
           <a:lstStyle/>
           <a:p>
             <a:pPr algn="ctr"/>
+            <a:endParaRPr/>
           </a:p>
         </p:txBody>
       </p:sp>
@@ -4267,7 +4300,7 @@
           <a:noFill/>
         </p:spPr>
         <p:txBody>
-          <a:bodyPr wrap="square" lIns="0" rIns="0" tIns="0" bIns="0" anchor="t">
+          <a:bodyPr wrap="square" lIns="0" tIns="0" rIns="0" bIns="0" anchor="t">
             <a:spAutoFit/>
           </a:bodyPr>
           <a:lstStyle/>
@@ -4302,7 +4335,7 @@
           <a:noFill/>
         </p:spPr>
         <p:txBody>
-          <a:bodyPr wrap="square" lIns="0" rIns="0" tIns="0" bIns="0" anchor="t">
+          <a:bodyPr wrap="square" lIns="0" tIns="0" rIns="0" bIns="0" anchor="t">
             <a:spAutoFit/>
           </a:bodyPr>
           <a:lstStyle/>
@@ -4337,7 +4370,7 @@
           <a:noFill/>
         </p:spPr>
         <p:txBody>
-          <a:bodyPr wrap="square" lIns="0" rIns="0" tIns="0" bIns="0" anchor="t">
+          <a:bodyPr wrap="square" lIns="0" tIns="0" rIns="0" bIns="0" anchor="t">
             <a:spAutoFit/>
           </a:bodyPr>
           <a:lstStyle/>
@@ -4410,6 +4443,7 @@
           <a:lstStyle/>
           <a:p>
             <a:pPr algn="ctr"/>
+            <a:endParaRPr/>
           </a:p>
         </p:txBody>
       </p:sp>
@@ -4430,7 +4464,7 @@
           <a:noFill/>
         </p:spPr>
         <p:txBody>
-          <a:bodyPr wrap="square" lIns="0" rIns="0" tIns="0" bIns="0" anchor="t">
+          <a:bodyPr wrap="square" lIns="0" tIns="0" rIns="0" bIns="0" anchor="t">
             <a:spAutoFit/>
           </a:bodyPr>
           <a:lstStyle/>
@@ -4465,7 +4499,7 @@
           <a:noFill/>
         </p:spPr>
         <p:txBody>
-          <a:bodyPr wrap="square" lIns="0" rIns="0" tIns="0" bIns="0" anchor="t">
+          <a:bodyPr wrap="square" lIns="0" tIns="0" rIns="0" bIns="0" anchor="t">
             <a:spAutoFit/>
           </a:bodyPr>
           <a:lstStyle/>
@@ -4500,7 +4534,7 @@
           <a:noFill/>
         </p:spPr>
         <p:txBody>
-          <a:bodyPr wrap="square" lIns="0" rIns="0" tIns="0" bIns="0" anchor="t">
+          <a:bodyPr wrap="square" lIns="0" tIns="0" rIns="0" bIns="0" anchor="t">
             <a:spAutoFit/>
           </a:bodyPr>
           <a:lstStyle/>
@@ -4561,6 +4595,7 @@
           <a:lstStyle/>
           <a:p>
             <a:pPr algn="ctr"/>
+            <a:endParaRPr/>
           </a:p>
         </p:txBody>
       </p:sp>
@@ -4581,7 +4616,7 @@
           <a:noFill/>
         </p:spPr>
         <p:txBody>
-          <a:bodyPr wrap="square" lIns="0" rIns="0" tIns="0" bIns="0" anchor="t">
+          <a:bodyPr wrap="square" lIns="0" tIns="0" rIns="0" bIns="0" anchor="t">
             <a:spAutoFit/>
           </a:bodyPr>
           <a:lstStyle/>
@@ -4616,7 +4651,7 @@
           <a:noFill/>
         </p:spPr>
         <p:txBody>
-          <a:bodyPr wrap="square" lIns="0" rIns="0" tIns="0" bIns="0" anchor="t">
+          <a:bodyPr wrap="square" lIns="0" tIns="0" rIns="0" bIns="0" anchor="t">
             <a:spAutoFit/>
           </a:bodyPr>
           <a:lstStyle/>
@@ -4651,7 +4686,7 @@
           <a:noFill/>
         </p:spPr>
         <p:txBody>
-          <a:bodyPr wrap="square" lIns="0" rIns="0" tIns="0" bIns="0" anchor="t">
+          <a:bodyPr wrap="square" lIns="0" tIns="0" rIns="0" bIns="0" anchor="t">
             <a:spAutoFit/>
           </a:bodyPr>
           <a:lstStyle/>
@@ -4712,6 +4747,7 @@
           <a:lstStyle/>
           <a:p>
             <a:pPr algn="ctr"/>
+            <a:endParaRPr/>
           </a:p>
         </p:txBody>
       </p:sp>
@@ -4732,7 +4768,7 @@
           <a:noFill/>
         </p:spPr>
         <p:txBody>
-          <a:bodyPr wrap="square" lIns="0" rIns="0" tIns="0" bIns="0" anchor="t">
+          <a:bodyPr wrap="square" lIns="0" tIns="0" rIns="0" bIns="0" anchor="t">
             <a:spAutoFit/>
           </a:bodyPr>
           <a:lstStyle/>
@@ -4767,7 +4803,7 @@
           <a:noFill/>
         </p:spPr>
         <p:txBody>
-          <a:bodyPr wrap="square" lIns="0" rIns="0" tIns="0" bIns="0" anchor="t">
+          <a:bodyPr wrap="square" lIns="0" tIns="0" rIns="0" bIns="0" anchor="t">
             <a:spAutoFit/>
           </a:bodyPr>
           <a:lstStyle/>
@@ -4802,7 +4838,7 @@
           <a:noFill/>
         </p:spPr>
         <p:txBody>
-          <a:bodyPr wrap="square" lIns="0" rIns="0" tIns="0" bIns="0" anchor="t">
+          <a:bodyPr wrap="square" lIns="0" tIns="0" rIns="0" bIns="0" anchor="t">
             <a:spAutoFit/>
           </a:bodyPr>
           <a:lstStyle/>
@@ -4863,6 +4899,7 @@
           <a:lstStyle/>
           <a:p>
             <a:pPr algn="ctr"/>
+            <a:endParaRPr/>
           </a:p>
         </p:txBody>
       </p:sp>
@@ -4883,7 +4920,7 @@
           <a:noFill/>
         </p:spPr>
         <p:txBody>
-          <a:bodyPr wrap="square" lIns="0" rIns="0" tIns="0" bIns="0" anchor="t">
+          <a:bodyPr wrap="square" lIns="0" tIns="0" rIns="0" bIns="0" anchor="t">
             <a:spAutoFit/>
           </a:bodyPr>
           <a:lstStyle/>
@@ -4918,7 +4955,7 @@
           <a:noFill/>
         </p:spPr>
         <p:txBody>
-          <a:bodyPr wrap="square" lIns="0" rIns="0" tIns="0" bIns="0" anchor="t">
+          <a:bodyPr wrap="square" lIns="0" tIns="0" rIns="0" bIns="0" anchor="t">
             <a:spAutoFit/>
           </a:bodyPr>
           <a:lstStyle/>
@@ -4953,7 +4990,7 @@
           <a:noFill/>
         </p:spPr>
         <p:txBody>
-          <a:bodyPr wrap="square" lIns="0" rIns="0" tIns="0" bIns="0" anchor="t">
+          <a:bodyPr wrap="square" lIns="0" tIns="0" rIns="0" bIns="0" anchor="t">
             <a:spAutoFit/>
           </a:bodyPr>
           <a:lstStyle/>
@@ -4988,7 +5025,7 @@
           <a:noFill/>
         </p:spPr>
         <p:txBody>
-          <a:bodyPr wrap="square" lIns="0" rIns="0" tIns="0" bIns="0" anchor="t">
+          <a:bodyPr wrap="square" lIns="0" tIns="0" rIns="0" bIns="0" anchor="t">
             <a:spAutoFit/>
           </a:bodyPr>
           <a:lstStyle/>
@@ -5023,7 +5060,7 @@
           <a:noFill/>
         </p:spPr>
         <p:txBody>
-          <a:bodyPr wrap="square" lIns="0" rIns="0" tIns="0" bIns="0" anchor="t">
+          <a:bodyPr wrap="square" lIns="0" tIns="0" rIns="0" bIns="0" anchor="t">
             <a:spAutoFit/>
           </a:bodyPr>
           <a:lstStyle/>
@@ -5050,7 +5087,7 @@
 </file>
 
 <file path=ppt/slides/slide4.xml><?xml version="1.0" encoding="utf-8"?>
-<p:sld xmlns:a="http://schemas.openxmlformats.org/drawingml/2006/main" xmlns:p="http://schemas.openxmlformats.org/presentationml/2006/main" xmlns:r="http://schemas.openxmlformats.org/officeDocument/2006/relationships">
+<p:sld xmlns:a="http://schemas.openxmlformats.org/drawingml/2006/main" xmlns:r="http://schemas.openxmlformats.org/officeDocument/2006/relationships" xmlns:p="http://schemas.openxmlformats.org/presentationml/2006/main">
   <p:cSld>
     <p:spTree>
       <p:nvGrpSpPr>
@@ -5058,7 +5095,14 @@
         <p:cNvGrpSpPr/>
         <p:nvPr/>
       </p:nvGrpSpPr>
-      <p:grpSpPr/>
+      <p:grpSpPr>
+        <a:xfrm>
+          <a:off x="0" y="0"/>
+          <a:ext cx="0" cy="0"/>
+          <a:chOff x="0" y="0"/>
+          <a:chExt cx="0" cy="0"/>
+        </a:xfrm>
+      </p:grpSpPr>
       <p:sp>
         <p:nvSpPr>
           <p:cNvPr id="2" name="Rectangle 1"/>
@@ -5100,6 +5144,7 @@
           <a:lstStyle/>
           <a:p>
             <a:pPr algn="ctr"/>
+            <a:endParaRPr/>
           </a:p>
         </p:txBody>
       </p:sp>
@@ -5120,7 +5165,7 @@
           <a:noFill/>
         </p:spPr>
         <p:txBody>
-          <a:bodyPr wrap="square" lIns="0" rIns="0" tIns="0" bIns="0" anchor="t">
+          <a:bodyPr wrap="square" lIns="0" tIns="0" rIns="0" bIns="0" anchor="t">
             <a:spAutoFit/>
           </a:bodyPr>
           <a:lstStyle/>
@@ -5155,7 +5200,7 @@
           <a:noFill/>
         </p:spPr>
         <p:txBody>
-          <a:bodyPr wrap="square" lIns="0" rIns="0" tIns="0" bIns="0" anchor="t">
+          <a:bodyPr wrap="square" lIns="0" tIns="0" rIns="0" bIns="0" anchor="t">
             <a:spAutoFit/>
           </a:bodyPr>
           <a:lstStyle/>
@@ -5190,7 +5235,7 @@
           <a:noFill/>
         </p:spPr>
         <p:txBody>
-          <a:bodyPr wrap="square" lIns="0" rIns="0" tIns="0" bIns="0" anchor="t">
+          <a:bodyPr wrap="square" lIns="0" tIns="0" rIns="0" bIns="0" anchor="t">
             <a:spAutoFit/>
           </a:bodyPr>
           <a:lstStyle/>
@@ -5251,6 +5296,7 @@
           <a:lstStyle/>
           <a:p>
             <a:pPr algn="ctr"/>
+            <a:endParaRPr/>
           </a:p>
         </p:txBody>
       </p:sp>
@@ -5295,7 +5341,7 @@
           <a:noFill/>
         </p:spPr>
         <p:txBody>
-          <a:bodyPr wrap="square" lIns="0" rIns="0" tIns="0" bIns="0" anchor="t">
+          <a:bodyPr wrap="square" lIns="0" tIns="0" rIns="0" bIns="0" anchor="t">
             <a:spAutoFit/>
           </a:bodyPr>
           <a:lstStyle/>
@@ -5356,6 +5402,7 @@
           <a:lstStyle/>
           <a:p>
             <a:pPr algn="ctr"/>
+            <a:endParaRPr/>
           </a:p>
         </p:txBody>
       </p:sp>
@@ -5400,7 +5447,7 @@
           <a:noFill/>
         </p:spPr>
         <p:txBody>
-          <a:bodyPr wrap="square" lIns="0" rIns="0" tIns="0" bIns="0" anchor="t">
+          <a:bodyPr wrap="square" lIns="0" tIns="0" rIns="0" bIns="0" anchor="t">
             <a:spAutoFit/>
           </a:bodyPr>
           <a:lstStyle/>
@@ -5461,6 +5508,7 @@
           <a:lstStyle/>
           <a:p>
             <a:pPr algn="ctr"/>
+            <a:endParaRPr/>
           </a:p>
         </p:txBody>
       </p:sp>
@@ -5505,7 +5553,7 @@
           <a:noFill/>
         </p:spPr>
         <p:txBody>
-          <a:bodyPr wrap="square" lIns="0" rIns="0" tIns="0" bIns="0" anchor="t">
+          <a:bodyPr wrap="square" lIns="0" tIns="0" rIns="0" bIns="0" anchor="t">
             <a:spAutoFit/>
           </a:bodyPr>
           <a:lstStyle/>
@@ -5540,7 +5588,7 @@
           <a:noFill/>
         </p:spPr>
         <p:txBody>
-          <a:bodyPr wrap="square" lIns="0" rIns="0" tIns="0" bIns="0" anchor="t">
+          <a:bodyPr wrap="square" lIns="0" tIns="0" rIns="0" bIns="0" anchor="t">
             <a:spAutoFit/>
           </a:bodyPr>
           <a:lstStyle/>
@@ -5575,7 +5623,7 @@
           <a:noFill/>
         </p:spPr>
         <p:txBody>
-          <a:bodyPr wrap="square" lIns="0" rIns="0" tIns="0" bIns="0" anchor="t">
+          <a:bodyPr wrap="square" lIns="0" tIns="0" rIns="0" bIns="0" anchor="t">
             <a:spAutoFit/>
           </a:bodyPr>
           <a:lstStyle/>
@@ -5602,7 +5650,7 @@
 </file>
 
 <file path=ppt/slides/slide5.xml><?xml version="1.0" encoding="utf-8"?>
-<p:sld xmlns:a="http://schemas.openxmlformats.org/drawingml/2006/main" xmlns:p="http://schemas.openxmlformats.org/presentationml/2006/main" xmlns:r="http://schemas.openxmlformats.org/officeDocument/2006/relationships">
+<p:sld xmlns:a="http://schemas.openxmlformats.org/drawingml/2006/main" xmlns:r="http://schemas.openxmlformats.org/officeDocument/2006/relationships" xmlns:p="http://schemas.openxmlformats.org/presentationml/2006/main">
   <p:cSld>
     <p:spTree>
       <p:nvGrpSpPr>
@@ -5610,7 +5658,14 @@
         <p:cNvGrpSpPr/>
         <p:nvPr/>
       </p:nvGrpSpPr>
-      <p:grpSpPr/>
+      <p:grpSpPr>
+        <a:xfrm>
+          <a:off x="0" y="0"/>
+          <a:ext cx="0" cy="0"/>
+          <a:chOff x="0" y="0"/>
+          <a:chExt cx="0" cy="0"/>
+        </a:xfrm>
+      </p:grpSpPr>
       <p:sp>
         <p:nvSpPr>
           <p:cNvPr id="2" name="Rectangle 1"/>
@@ -5652,6 +5707,7 @@
           <a:lstStyle/>
           <a:p>
             <a:pPr algn="ctr"/>
+            <a:endParaRPr/>
           </a:p>
         </p:txBody>
       </p:sp>
@@ -5672,7 +5728,7 @@
           <a:noFill/>
         </p:spPr>
         <p:txBody>
-          <a:bodyPr wrap="square" lIns="0" rIns="0" tIns="0" bIns="0" anchor="t">
+          <a:bodyPr wrap="square" lIns="0" tIns="0" rIns="0" bIns="0" anchor="t">
             <a:spAutoFit/>
           </a:bodyPr>
           <a:lstStyle/>
@@ -5707,7 +5763,7 @@
           <a:noFill/>
         </p:spPr>
         <p:txBody>
-          <a:bodyPr wrap="square" lIns="0" rIns="0" tIns="0" bIns="0" anchor="t">
+          <a:bodyPr wrap="square" lIns="0" tIns="0" rIns="0" bIns="0" anchor="t">
             <a:spAutoFit/>
           </a:bodyPr>
           <a:lstStyle/>
@@ -5768,6 +5824,7 @@
           <a:lstStyle/>
           <a:p>
             <a:pPr algn="ctr"/>
+            <a:endParaRPr/>
           </a:p>
         </p:txBody>
       </p:sp>
@@ -5788,7 +5845,7 @@
           <a:noFill/>
         </p:spPr>
         <p:txBody>
-          <a:bodyPr wrap="square" lIns="0" rIns="0" tIns="0" bIns="0" anchor="t">
+          <a:bodyPr wrap="square" lIns="0" tIns="0" rIns="0" bIns="0" anchor="t">
             <a:spAutoFit/>
           </a:bodyPr>
           <a:lstStyle/>
@@ -5823,7 +5880,7 @@
           <a:noFill/>
         </p:spPr>
         <p:txBody>
-          <a:bodyPr wrap="square" lIns="0" rIns="0" tIns="0" bIns="0" anchor="t">
+          <a:bodyPr wrap="square" lIns="0" tIns="0" rIns="0" bIns="0" anchor="t">
             <a:spAutoFit/>
           </a:bodyPr>
           <a:lstStyle/>
@@ -5858,7 +5915,7 @@
           <a:noFill/>
         </p:spPr>
         <p:txBody>
-          <a:bodyPr wrap="square" lIns="0" rIns="0" tIns="0" bIns="0" anchor="t">
+          <a:bodyPr wrap="square" lIns="0" tIns="0" rIns="0" bIns="0" anchor="t">
             <a:spAutoFit/>
           </a:bodyPr>
           <a:lstStyle/>
@@ -5893,7 +5950,7 @@
           <a:noFill/>
         </p:spPr>
         <p:txBody>
-          <a:bodyPr wrap="square" lIns="0" rIns="0" tIns="0" bIns="0" anchor="t">
+          <a:bodyPr wrap="square" lIns="0" tIns="0" rIns="0" bIns="0" anchor="t">
             <a:spAutoFit/>
           </a:bodyPr>
           <a:lstStyle/>
@@ -5954,6 +6011,7 @@
           <a:lstStyle/>
           <a:p>
             <a:pPr algn="ctr"/>
+            <a:endParaRPr/>
           </a:p>
         </p:txBody>
       </p:sp>
@@ -5974,7 +6032,7 @@
           <a:noFill/>
         </p:spPr>
         <p:txBody>
-          <a:bodyPr wrap="square" lIns="0" rIns="0" tIns="0" bIns="0" anchor="t">
+          <a:bodyPr wrap="square" lIns="0" tIns="0" rIns="0" bIns="0" anchor="t">
             <a:spAutoFit/>
           </a:bodyPr>
           <a:lstStyle/>
@@ -6009,7 +6067,7 @@
           <a:noFill/>
         </p:spPr>
         <p:txBody>
-          <a:bodyPr wrap="square" lIns="0" rIns="0" tIns="0" bIns="0" anchor="t">
+          <a:bodyPr wrap="square" lIns="0" tIns="0" rIns="0" bIns="0" anchor="t">
             <a:spAutoFit/>
           </a:bodyPr>
           <a:lstStyle/>
@@ -6044,7 +6102,7 @@
           <a:noFill/>
         </p:spPr>
         <p:txBody>
-          <a:bodyPr wrap="square" lIns="0" rIns="0" tIns="0" bIns="0" anchor="t">
+          <a:bodyPr wrap="square" lIns="0" tIns="0" rIns="0" bIns="0" anchor="t">
             <a:spAutoFit/>
           </a:bodyPr>
           <a:lstStyle/>
@@ -6079,7 +6137,7 @@
           <a:noFill/>
         </p:spPr>
         <p:txBody>
-          <a:bodyPr wrap="square" lIns="0" rIns="0" tIns="0" bIns="0" anchor="t">
+          <a:bodyPr wrap="square" lIns="0" tIns="0" rIns="0" bIns="0" anchor="t">
             <a:spAutoFit/>
           </a:bodyPr>
           <a:lstStyle/>
@@ -6140,6 +6198,7 @@
           <a:lstStyle/>
           <a:p>
             <a:pPr algn="ctr"/>
+            <a:endParaRPr/>
           </a:p>
         </p:txBody>
       </p:sp>
@@ -6160,7 +6219,7 @@
           <a:noFill/>
         </p:spPr>
         <p:txBody>
-          <a:bodyPr wrap="square" lIns="0" rIns="0" tIns="0" bIns="0" anchor="t">
+          <a:bodyPr wrap="square" lIns="0" tIns="0" rIns="0" bIns="0" anchor="t">
             <a:spAutoFit/>
           </a:bodyPr>
           <a:lstStyle/>
@@ -6195,7 +6254,7 @@
           <a:noFill/>
         </p:spPr>
         <p:txBody>
-          <a:bodyPr wrap="square" lIns="0" rIns="0" tIns="0" bIns="0" anchor="t">
+          <a:bodyPr wrap="square" lIns="0" tIns="0" rIns="0" bIns="0" anchor="t">
             <a:spAutoFit/>
           </a:bodyPr>
           <a:lstStyle/>
@@ -6230,7 +6289,7 @@
           <a:noFill/>
         </p:spPr>
         <p:txBody>
-          <a:bodyPr wrap="square" lIns="0" rIns="0" tIns="0" bIns="0" anchor="t">
+          <a:bodyPr wrap="square" lIns="0" tIns="0" rIns="0" bIns="0" anchor="t">
             <a:spAutoFit/>
           </a:bodyPr>
           <a:lstStyle/>
@@ -6265,7 +6324,7 @@
           <a:noFill/>
         </p:spPr>
         <p:txBody>
-          <a:bodyPr wrap="square" lIns="0" rIns="0" tIns="0" bIns="0" anchor="t">
+          <a:bodyPr wrap="square" lIns="0" tIns="0" rIns="0" bIns="0" anchor="t">
             <a:spAutoFit/>
           </a:bodyPr>
           <a:lstStyle/>
@@ -6326,6 +6385,7 @@
           <a:lstStyle/>
           <a:p>
             <a:pPr algn="ctr"/>
+            <a:endParaRPr/>
           </a:p>
         </p:txBody>
       </p:sp>
@@ -6346,7 +6406,7 @@
           <a:noFill/>
         </p:spPr>
         <p:txBody>
-          <a:bodyPr wrap="square" lIns="0" rIns="0" tIns="0" bIns="0" anchor="t">
+          <a:bodyPr wrap="square" lIns="0" tIns="0" rIns="0" bIns="0" anchor="t">
             <a:spAutoFit/>
           </a:bodyPr>
           <a:lstStyle/>
@@ -6381,7 +6441,7 @@
           <a:noFill/>
         </p:spPr>
         <p:txBody>
-          <a:bodyPr wrap="square" lIns="0" rIns="0" tIns="0" bIns="0" anchor="t">
+          <a:bodyPr wrap="square" lIns="0" tIns="0" rIns="0" bIns="0" anchor="t">
             <a:spAutoFit/>
           </a:bodyPr>
           <a:lstStyle/>
@@ -6416,7 +6476,7 @@
           <a:noFill/>
         </p:spPr>
         <p:txBody>
-          <a:bodyPr wrap="square" lIns="0" rIns="0" tIns="0" bIns="0" anchor="t">
+          <a:bodyPr wrap="square" lIns="0" tIns="0" rIns="0" bIns="0" anchor="t">
             <a:spAutoFit/>
           </a:bodyPr>
           <a:lstStyle/>
@@ -6477,6 +6537,7 @@
           <a:lstStyle/>
           <a:p>
             <a:pPr algn="ctr"/>
+            <a:endParaRPr/>
           </a:p>
         </p:txBody>
       </p:sp>
@@ -6497,7 +6558,7 @@
           <a:noFill/>
         </p:spPr>
         <p:txBody>
-          <a:bodyPr wrap="square" lIns="0" rIns="0" tIns="0" bIns="0" anchor="t">
+          <a:bodyPr wrap="square" lIns="0" tIns="0" rIns="0" bIns="0" anchor="t">
             <a:spAutoFit/>
           </a:bodyPr>
           <a:lstStyle/>
@@ -6532,7 +6593,7 @@
           <a:noFill/>
         </p:spPr>
         <p:txBody>
-          <a:bodyPr wrap="square" lIns="0" rIns="0" tIns="0" bIns="0" anchor="t">
+          <a:bodyPr wrap="square" lIns="0" tIns="0" rIns="0" bIns="0" anchor="t">
             <a:spAutoFit/>
           </a:bodyPr>
           <a:lstStyle/>
@@ -6567,7 +6628,7 @@
           <a:noFill/>
         </p:spPr>
         <p:txBody>
-          <a:bodyPr wrap="square" lIns="0" rIns="0" tIns="0" bIns="0" anchor="t">
+          <a:bodyPr wrap="square" lIns="0" tIns="0" rIns="0" bIns="0" anchor="t">
             <a:spAutoFit/>
           </a:bodyPr>
           <a:lstStyle/>
@@ -6602,7 +6663,7 @@
           <a:noFill/>
         </p:spPr>
         <p:txBody>
-          <a:bodyPr wrap="square" lIns="0" rIns="0" tIns="0" bIns="0" anchor="t">
+          <a:bodyPr wrap="square" lIns="0" tIns="0" rIns="0" bIns="0" anchor="t">
             <a:spAutoFit/>
           </a:bodyPr>
           <a:lstStyle/>
@@ -6629,7 +6690,7 @@
 </file>
 
 <file path=ppt/slides/slide6.xml><?xml version="1.0" encoding="utf-8"?>
-<p:sld xmlns:a="http://schemas.openxmlformats.org/drawingml/2006/main" xmlns:p="http://schemas.openxmlformats.org/presentationml/2006/main" xmlns:r="http://schemas.openxmlformats.org/officeDocument/2006/relationships">
+<p:sld xmlns:a="http://schemas.openxmlformats.org/drawingml/2006/main" xmlns:r="http://schemas.openxmlformats.org/officeDocument/2006/relationships" xmlns:p="http://schemas.openxmlformats.org/presentationml/2006/main">
   <p:cSld>
     <p:spTree>
       <p:nvGrpSpPr>
@@ -6637,7 +6698,14 @@
         <p:cNvGrpSpPr/>
         <p:nvPr/>
       </p:nvGrpSpPr>
-      <p:grpSpPr/>
+      <p:grpSpPr>
+        <a:xfrm>
+          <a:off x="0" y="0"/>
+          <a:ext cx="0" cy="0"/>
+          <a:chOff x="0" y="0"/>
+          <a:chExt cx="0" cy="0"/>
+        </a:xfrm>
+      </p:grpSpPr>
       <p:sp>
         <p:nvSpPr>
           <p:cNvPr id="2" name="Rectangle 1"/>
@@ -6679,6 +6747,7 @@
           <a:lstStyle/>
           <a:p>
             <a:pPr algn="ctr"/>
+            <a:endParaRPr/>
           </a:p>
         </p:txBody>
       </p:sp>
@@ -6699,7 +6768,7 @@
           <a:noFill/>
         </p:spPr>
         <p:txBody>
-          <a:bodyPr wrap="square" lIns="0" rIns="0" tIns="0" bIns="0" anchor="t">
+          <a:bodyPr wrap="square" lIns="0" tIns="0" rIns="0" bIns="0" anchor="t">
             <a:spAutoFit/>
           </a:bodyPr>
           <a:lstStyle/>
@@ -6734,7 +6803,7 @@
           <a:noFill/>
         </p:spPr>
         <p:txBody>
-          <a:bodyPr wrap="square" lIns="0" rIns="0" tIns="0" bIns="0" anchor="t">
+          <a:bodyPr wrap="square" lIns="0" tIns="0" rIns="0" bIns="0" anchor="t">
             <a:spAutoFit/>
           </a:bodyPr>
           <a:lstStyle/>
@@ -6769,7 +6838,7 @@
           <a:noFill/>
         </p:spPr>
         <p:txBody>
-          <a:bodyPr wrap="square" lIns="0" rIns="0" tIns="0" bIns="0" anchor="t">
+          <a:bodyPr wrap="square" lIns="0" tIns="0" rIns="0" bIns="0" anchor="t">
             <a:spAutoFit/>
           </a:bodyPr>
           <a:lstStyle/>
@@ -6830,6 +6899,7 @@
           <a:lstStyle/>
           <a:p>
             <a:pPr algn="ctr"/>
+            <a:endParaRPr/>
           </a:p>
         </p:txBody>
       </p:sp>
@@ -6874,6 +6944,7 @@
           <a:lstStyle/>
           <a:p>
             <a:pPr algn="ctr"/>
+            <a:endParaRPr/>
           </a:p>
         </p:txBody>
       </p:sp>
@@ -6894,7 +6965,7 @@
           <a:noFill/>
         </p:spPr>
         <p:txBody>
-          <a:bodyPr wrap="square" lIns="0" rIns="0" tIns="0" bIns="0" anchor="t">
+          <a:bodyPr wrap="square" lIns="0" tIns="0" rIns="0" bIns="0" anchor="t">
             <a:spAutoFit/>
           </a:bodyPr>
           <a:lstStyle/>
@@ -6929,7 +7000,7 @@
           <a:noFill/>
         </p:spPr>
         <p:txBody>
-          <a:bodyPr wrap="square" lIns="0" rIns="0" tIns="0" bIns="0" anchor="t">
+          <a:bodyPr wrap="square" lIns="0" tIns="0" rIns="0" bIns="0" anchor="t">
             <a:spAutoFit/>
           </a:bodyPr>
           <a:lstStyle/>
@@ -6964,7 +7035,7 @@
           <a:noFill/>
         </p:spPr>
         <p:txBody>
-          <a:bodyPr wrap="square" lIns="0" rIns="0" tIns="0" bIns="0" anchor="t">
+          <a:bodyPr wrap="square" lIns="0" tIns="0" rIns="0" bIns="0" anchor="t">
             <a:spAutoFit/>
           </a:bodyPr>
           <a:lstStyle/>
@@ -6999,7 +7070,7 @@
           <a:noFill/>
         </p:spPr>
         <p:txBody>
-          <a:bodyPr wrap="square" lIns="0" rIns="0" tIns="0" bIns="0" anchor="t">
+          <a:bodyPr wrap="square" lIns="0" tIns="0" rIns="0" bIns="0" anchor="t">
             <a:spAutoFit/>
           </a:bodyPr>
           <a:lstStyle/>
@@ -7060,6 +7131,7 @@
           <a:lstStyle/>
           <a:p>
             <a:pPr algn="ctr"/>
+            <a:endParaRPr/>
           </a:p>
         </p:txBody>
       </p:sp>
@@ -7104,6 +7176,7 @@
           <a:lstStyle/>
           <a:p>
             <a:pPr algn="ctr"/>
+            <a:endParaRPr/>
           </a:p>
         </p:txBody>
       </p:sp>
@@ -7124,7 +7197,7 @@
           <a:noFill/>
         </p:spPr>
         <p:txBody>
-          <a:bodyPr wrap="square" lIns="0" rIns="0" tIns="0" bIns="0" anchor="t">
+          <a:bodyPr wrap="square" lIns="0" tIns="0" rIns="0" bIns="0" anchor="t">
             <a:spAutoFit/>
           </a:bodyPr>
           <a:lstStyle/>
@@ -7159,7 +7232,7 @@
           <a:noFill/>
         </p:spPr>
         <p:txBody>
-          <a:bodyPr wrap="square" lIns="0" rIns="0" tIns="0" bIns="0" anchor="t">
+          <a:bodyPr wrap="square" lIns="0" tIns="0" rIns="0" bIns="0" anchor="t">
             <a:spAutoFit/>
           </a:bodyPr>
           <a:lstStyle/>
@@ -7194,7 +7267,7 @@
           <a:noFill/>
         </p:spPr>
         <p:txBody>
-          <a:bodyPr wrap="square" lIns="0" rIns="0" tIns="0" bIns="0" anchor="t">
+          <a:bodyPr wrap="square" lIns="0" tIns="0" rIns="0" bIns="0" anchor="t">
             <a:spAutoFit/>
           </a:bodyPr>
           <a:lstStyle/>
@@ -7229,7 +7302,7 @@
           <a:noFill/>
         </p:spPr>
         <p:txBody>
-          <a:bodyPr wrap="square" lIns="0" rIns="0" tIns="0" bIns="0" anchor="t">
+          <a:bodyPr wrap="square" lIns="0" tIns="0" rIns="0" bIns="0" anchor="t">
             <a:spAutoFit/>
           </a:bodyPr>
           <a:lstStyle/>
@@ -7290,6 +7363,7 @@
           <a:lstStyle/>
           <a:p>
             <a:pPr algn="ctr"/>
+            <a:endParaRPr/>
           </a:p>
         </p:txBody>
       </p:sp>
@@ -7334,6 +7408,7 @@
           <a:lstStyle/>
           <a:p>
             <a:pPr algn="ctr"/>
+            <a:endParaRPr/>
           </a:p>
         </p:txBody>
       </p:sp>
@@ -7354,7 +7429,7 @@
           <a:noFill/>
         </p:spPr>
         <p:txBody>
-          <a:bodyPr wrap="square" lIns="0" rIns="0" tIns="0" bIns="0" anchor="t">
+          <a:bodyPr wrap="square" lIns="0" tIns="0" rIns="0" bIns="0" anchor="t">
             <a:spAutoFit/>
           </a:bodyPr>
           <a:lstStyle/>
@@ -7389,7 +7464,7 @@
           <a:noFill/>
         </p:spPr>
         <p:txBody>
-          <a:bodyPr wrap="square" lIns="0" rIns="0" tIns="0" bIns="0" anchor="t">
+          <a:bodyPr wrap="square" lIns="0" tIns="0" rIns="0" bIns="0" anchor="t">
             <a:spAutoFit/>
           </a:bodyPr>
           <a:lstStyle/>
@@ -7424,7 +7499,7 @@
           <a:noFill/>
         </p:spPr>
         <p:txBody>
-          <a:bodyPr wrap="square" lIns="0" rIns="0" tIns="0" bIns="0" anchor="t">
+          <a:bodyPr wrap="square" lIns="0" tIns="0" rIns="0" bIns="0" anchor="t">
             <a:spAutoFit/>
           </a:bodyPr>
           <a:lstStyle/>
@@ -7459,7 +7534,7 @@
           <a:noFill/>
         </p:spPr>
         <p:txBody>
-          <a:bodyPr wrap="square" lIns="0" rIns="0" tIns="0" bIns="0" anchor="t">
+          <a:bodyPr wrap="square" lIns="0" tIns="0" rIns="0" bIns="0" anchor="t">
             <a:spAutoFit/>
           </a:bodyPr>
           <a:lstStyle/>
@@ -7520,6 +7595,7 @@
           <a:lstStyle/>
           <a:p>
             <a:pPr algn="ctr"/>
+            <a:endParaRPr/>
           </a:p>
         </p:txBody>
       </p:sp>
@@ -7564,6 +7640,7 @@
           <a:lstStyle/>
           <a:p>
             <a:pPr algn="ctr"/>
+            <a:endParaRPr/>
           </a:p>
         </p:txBody>
       </p:sp>
@@ -7584,7 +7661,7 @@
           <a:noFill/>
         </p:spPr>
         <p:txBody>
-          <a:bodyPr wrap="square" lIns="0" rIns="0" tIns="0" bIns="0" anchor="t">
+          <a:bodyPr wrap="square" lIns="0" tIns="0" rIns="0" bIns="0" anchor="t">
             <a:spAutoFit/>
           </a:bodyPr>
           <a:lstStyle/>
@@ -7619,7 +7696,7 @@
           <a:noFill/>
         </p:spPr>
         <p:txBody>
-          <a:bodyPr wrap="square" lIns="0" rIns="0" tIns="0" bIns="0" anchor="t">
+          <a:bodyPr wrap="square" lIns="0" tIns="0" rIns="0" bIns="0" anchor="t">
             <a:spAutoFit/>
           </a:bodyPr>
           <a:lstStyle/>
@@ -7654,7 +7731,7 @@
           <a:noFill/>
         </p:spPr>
         <p:txBody>
-          <a:bodyPr wrap="square" lIns="0" rIns="0" tIns="0" bIns="0" anchor="t">
+          <a:bodyPr wrap="square" lIns="0" tIns="0" rIns="0" bIns="0" anchor="t">
             <a:spAutoFit/>
           </a:bodyPr>
           <a:lstStyle/>
@@ -7689,7 +7766,7 @@
           <a:noFill/>
         </p:spPr>
         <p:txBody>
-          <a:bodyPr wrap="square" lIns="0" rIns="0" tIns="0" bIns="0" anchor="t">
+          <a:bodyPr wrap="square" lIns="0" tIns="0" rIns="0" bIns="0" anchor="t">
             <a:spAutoFit/>
           </a:bodyPr>
           <a:lstStyle/>
@@ -7724,7 +7801,7 @@
           <a:noFill/>
         </p:spPr>
         <p:txBody>
-          <a:bodyPr wrap="square" lIns="0" rIns="0" tIns="0" bIns="0" anchor="t">
+          <a:bodyPr wrap="square" lIns="0" tIns="0" rIns="0" bIns="0" anchor="t">
             <a:spAutoFit/>
           </a:bodyPr>
           <a:lstStyle/>
@@ -7751,7 +7828,7 @@
 </file>
 
 <file path=ppt/slides/slide7.xml><?xml version="1.0" encoding="utf-8"?>
-<p:sld xmlns:a="http://schemas.openxmlformats.org/drawingml/2006/main" xmlns:p="http://schemas.openxmlformats.org/presentationml/2006/main" xmlns:r="http://schemas.openxmlformats.org/officeDocument/2006/relationships">
+<p:sld xmlns:a="http://schemas.openxmlformats.org/drawingml/2006/main" xmlns:r="http://schemas.openxmlformats.org/officeDocument/2006/relationships" xmlns:p="http://schemas.openxmlformats.org/presentationml/2006/main">
   <p:cSld>
     <p:spTree>
       <p:nvGrpSpPr>
@@ -7759,7 +7836,14 @@
         <p:cNvGrpSpPr/>
         <p:nvPr/>
       </p:nvGrpSpPr>
-      <p:grpSpPr/>
+      <p:grpSpPr>
+        <a:xfrm>
+          <a:off x="0" y="0"/>
+          <a:ext cx="0" cy="0"/>
+          <a:chOff x="0" y="0"/>
+          <a:chExt cx="0" cy="0"/>
+        </a:xfrm>
+      </p:grpSpPr>
       <p:sp>
         <p:nvSpPr>
           <p:cNvPr id="2" name="Rectangle 1"/>
@@ -7801,6 +7885,7 @@
           <a:lstStyle/>
           <a:p>
             <a:pPr algn="ctr"/>
+            <a:endParaRPr/>
           </a:p>
         </p:txBody>
       </p:sp>
@@ -7821,7 +7906,7 @@
           <a:noFill/>
         </p:spPr>
         <p:txBody>
-          <a:bodyPr wrap="square" lIns="0" rIns="0" tIns="0" bIns="0" anchor="t">
+          <a:bodyPr wrap="square" lIns="0" tIns="0" rIns="0" bIns="0" anchor="t">
             <a:spAutoFit/>
           </a:bodyPr>
           <a:lstStyle/>
@@ -7834,7 +7919,7 @@
                 </a:solidFill>
                 <a:latin typeface="Inter"/>
               </a:rPr>
-              <a:t>TIMELINE + PRICING</a:t>
+              <a:t>ABOUT MICHAEL WEGTER</a:t>
             </a:r>
           </a:p>
         </p:txBody>
@@ -7856,7 +7941,7 @@
           <a:noFill/>
         </p:spPr>
         <p:txBody>
-          <a:bodyPr wrap="square" lIns="0" rIns="0" tIns="0" bIns="0" anchor="t">
+          <a:bodyPr wrap="square" lIns="0" tIns="0" rIns="0" bIns="0" anchor="t">
             <a:spAutoFit/>
           </a:bodyPr>
           <a:lstStyle/>
@@ -7869,172 +7954,56 @@
                 </a:solidFill>
                 <a:latin typeface="DM Sans"/>
               </a:rPr>
-              <a:t>Fixed price. Scope is clear, delivery is bounded.</a:t>
-            </a:r>
-          </a:p>
-        </p:txBody>
-      </p:sp>
-      <p:sp>
-        <p:nvSpPr>
-          <p:cNvPr id="5" name="Rectangle 4"/>
+              <a:t>Full-stack developer, currently based in the United States</a:t>
+            </a:r>
+          </a:p>
+        </p:txBody>
+      </p:sp>
+      <p:sp>
+        <p:nvSpPr>
+          <p:cNvPr id="5" name="TextBox 4"/>
+          <p:cNvSpPr txBox="1"/>
+          <p:nvPr/>
+        </p:nvSpPr>
+        <p:spPr>
+          <a:xfrm>
+            <a:off x="822960" y="1783080"/>
+            <a:ext cx="9144000" cy="502920"/>
+          </a:xfrm>
+          <a:prstGeom prst="rect">
+            <a:avLst/>
+          </a:prstGeom>
+          <a:noFill/>
+        </p:spPr>
+        <p:txBody>
+          <a:bodyPr wrap="square" lIns="0" tIns="0" rIns="0" bIns="0" anchor="t">
+            <a:spAutoFit/>
+          </a:bodyPr>
+          <a:lstStyle/>
+          <a:p>
+            <a:pPr algn="l"/>
+            <a:r>
+              <a:rPr sz="1400" b="0">
+                <a:solidFill>
+                  <a:srgbClr val="CBD5E1"/>
+                </a:solidFill>
+                <a:latin typeface="Inter"/>
+              </a:rPr>
+              <a:t>I confirmed: I am currently based in the United States. I have built the stack this project requires and ship AI-assisted features daily.</a:t>
+            </a:r>
+          </a:p>
+        </p:txBody>
+      </p:sp>
+      <p:sp>
+        <p:nvSpPr>
+          <p:cNvPr id="6" name="Rectangle 5"/>
           <p:cNvSpPr/>
           <p:nvPr/>
         </p:nvSpPr>
         <p:spPr>
           <a:xfrm>
-            <a:off x="640080" y="1920240"/>
-            <a:ext cx="3383280" cy="2286000"/>
-          </a:xfrm>
-          <a:prstGeom prst="rect">
-            <a:avLst/>
-          </a:prstGeom>
-          <a:solidFill>
-            <a:srgbClr val="1E3A5F"/>
-          </a:solidFill>
-          <a:ln w="19050">
-            <a:solidFill>
-              <a:srgbClr val="2563EB"/>
-            </a:solidFill>
-          </a:ln>
-          <a:effectLst/>
-        </p:spPr>
-        <p:style>
-          <a:lnRef idx="1">
-            <a:schemeClr val="accent1"/>
-          </a:lnRef>
-          <a:fillRef idx="3">
-            <a:schemeClr val="accent1"/>
-          </a:fillRef>
-          <a:effectRef idx="2">
-            <a:schemeClr val="accent1"/>
-          </a:effectRef>
-          <a:fontRef idx="minor">
-            <a:schemeClr val="lt1"/>
-          </a:fontRef>
-        </p:style>
-        <p:txBody>
-          <a:bodyPr rtlCol="0" anchor="ctr"/>
-          <a:lstStyle/>
-          <a:p>
-            <a:pPr algn="ctr"/>
-          </a:p>
-        </p:txBody>
-      </p:sp>
-      <p:sp>
-        <p:nvSpPr>
-          <p:cNvPr id="6" name="TextBox 5"/>
-          <p:cNvSpPr txBox="1"/>
-          <p:nvPr/>
-        </p:nvSpPr>
-        <p:spPr>
-          <a:xfrm>
-            <a:off x="841248" y="2103120"/>
-            <a:ext cx="2980944" cy="274320"/>
-          </a:xfrm>
-          <a:prstGeom prst="rect">
-            <a:avLst/>
-          </a:prstGeom>
-          <a:noFill/>
-        </p:spPr>
-        <p:txBody>
-          <a:bodyPr wrap="square" lIns="0" rIns="0" tIns="0" bIns="0" anchor="t">
-            <a:spAutoFit/>
-          </a:bodyPr>
-          <a:lstStyle/>
-          <a:p>
-            <a:pPr algn="l"/>
-            <a:r>
-              <a:rPr sz="1000" b="1">
-                <a:solidFill>
-                  <a:srgbClr val="10B981"/>
-                </a:solidFill>
-                <a:latin typeface="Inter"/>
-              </a:rPr>
-              <a:t>BASE BUILD</a:t>
-            </a:r>
-          </a:p>
-        </p:txBody>
-      </p:sp>
-      <p:sp>
-        <p:nvSpPr>
-          <p:cNvPr id="7" name="TextBox 6"/>
-          <p:cNvSpPr txBox="1"/>
-          <p:nvPr/>
-        </p:nvSpPr>
-        <p:spPr>
-          <a:xfrm>
-            <a:off x="841248" y="2514600"/>
-            <a:ext cx="2980944" cy="640080"/>
-          </a:xfrm>
-          <a:prstGeom prst="rect">
-            <a:avLst/>
-          </a:prstGeom>
-          <a:noFill/>
-        </p:spPr>
-        <p:txBody>
-          <a:bodyPr wrap="square" lIns="0" rIns="0" tIns="0" bIns="0" anchor="t">
-            <a:spAutoFit/>
-          </a:bodyPr>
-          <a:lstStyle/>
-          <a:p>
-            <a:pPr algn="l"/>
-            <a:r>
-              <a:rPr sz="3600" b="1">
-                <a:solidFill>
-                  <a:srgbClr val="3799F8"/>
-                </a:solidFill>
-                <a:latin typeface="DM Sans"/>
-              </a:rPr>
-              <a:t>$2,500</a:t>
-            </a:r>
-          </a:p>
-        </p:txBody>
-      </p:sp>
-      <p:sp>
-        <p:nvSpPr>
-          <p:cNvPr id="8" name="TextBox 7"/>
-          <p:cNvSpPr txBox="1"/>
-          <p:nvPr/>
-        </p:nvSpPr>
-        <p:spPr>
-          <a:xfrm>
-            <a:off x="841248" y="3246120"/>
-            <a:ext cx="2980944" cy="868680"/>
-          </a:xfrm>
-          <a:prstGeom prst="rect">
-            <a:avLst/>
-          </a:prstGeom>
-          <a:noFill/>
-        </p:spPr>
-        <p:txBody>
-          <a:bodyPr wrap="square" lIns="0" rIns="0" tIns="0" bIns="0" anchor="t">
-            <a:spAutoFit/>
-          </a:bodyPr>
-          <a:lstStyle/>
-          <a:p>
-            <a:pPr algn="l"/>
-            <a:r>
-              <a:rPr sz="1200" b="0">
-                <a:solidFill>
-                  <a:srgbClr val="94A3B8"/>
-                </a:solidFill>
-                <a:latin typeface="Inter"/>
-              </a:rPr>
-              <a:t>In-browser chatbot, FAQ KB, order lookup, escalation, admin panel, embed code + docs</a:t>
-            </a:r>
-          </a:p>
-        </p:txBody>
-      </p:sp>
-      <p:sp>
-        <p:nvSpPr>
-          <p:cNvPr id="9" name="Rectangle 8"/>
-          <p:cNvSpPr/>
-          <p:nvPr/>
-        </p:nvSpPr>
-        <p:spPr>
-          <a:xfrm>
-            <a:off x="4343400" y="1920240"/>
-            <a:ext cx="3383280" cy="2286000"/>
+            <a:off x="822960" y="2514600"/>
+            <a:ext cx="5212080" cy="1508760"/>
           </a:xfrm>
           <a:prstGeom prst="rect">
             <a:avLst/>
@@ -8068,124 +8037,90 @@
           <a:lstStyle/>
           <a:p>
             <a:pPr algn="ctr"/>
-          </a:p>
-        </p:txBody>
-      </p:sp>
-      <p:sp>
-        <p:nvSpPr>
-          <p:cNvPr id="10" name="TextBox 9"/>
-          <p:cNvSpPr txBox="1"/>
-          <p:nvPr/>
-        </p:nvSpPr>
-        <p:spPr>
-          <a:xfrm>
-            <a:off x="4544568" y="2103120"/>
-            <a:ext cx="2980944" cy="274320"/>
-          </a:xfrm>
-          <a:prstGeom prst="rect">
-            <a:avLst/>
-          </a:prstGeom>
-          <a:noFill/>
-        </p:spPr>
-        <p:txBody>
-          <a:bodyPr wrap="square" lIns="0" rIns="0" tIns="0" bIns="0" anchor="t">
-            <a:spAutoFit/>
-          </a:bodyPr>
-          <a:lstStyle/>
-          <a:p>
-            <a:pPr algn="l"/>
-            <a:r>
-              <a:rPr sz="1000" b="1">
+            <a:endParaRPr/>
+          </a:p>
+        </p:txBody>
+      </p:sp>
+      <p:sp>
+        <p:nvSpPr>
+          <p:cNvPr id="7" name="TextBox 6"/>
+          <p:cNvSpPr txBox="1"/>
+          <p:nvPr/>
+        </p:nvSpPr>
+        <p:spPr>
+          <a:xfrm>
+            <a:off x="1005840" y="2679192"/>
+            <a:ext cx="4846320" cy="320040"/>
+          </a:xfrm>
+          <a:prstGeom prst="rect">
+            <a:avLst/>
+          </a:prstGeom>
+          <a:noFill/>
+        </p:spPr>
+        <p:txBody>
+          <a:bodyPr wrap="square" lIns="0" tIns="0" rIns="0" bIns="0" anchor="t">
+            <a:spAutoFit/>
+          </a:bodyPr>
+          <a:lstStyle/>
+          <a:p>
+            <a:pPr algn="l"/>
+            <a:r>
+              <a:rPr sz="1400" b="1">
+                <a:solidFill>
+                  <a:srgbClr val="F8FAFC"/>
+                </a:solidFill>
+                <a:latin typeface="DM Sans"/>
+              </a:rPr>
+              <a:t>2.5 years at U.S. Bank</a:t>
+            </a:r>
+          </a:p>
+        </p:txBody>
+      </p:sp>
+      <p:sp>
+        <p:nvSpPr>
+          <p:cNvPr id="8" name="TextBox 7"/>
+          <p:cNvSpPr txBox="1"/>
+          <p:nvPr/>
+        </p:nvSpPr>
+        <p:spPr>
+          <a:xfrm>
+            <a:off x="1005840" y="3063240"/>
+            <a:ext cx="4846320" cy="822960"/>
+          </a:xfrm>
+          <a:prstGeom prst="rect">
+            <a:avLst/>
+          </a:prstGeom>
+          <a:noFill/>
+        </p:spPr>
+        <p:txBody>
+          <a:bodyPr wrap="square" lIns="0" tIns="0" rIns="0" bIns="0" anchor="t">
+            <a:spAutoFit/>
+          </a:bodyPr>
+          <a:lstStyle/>
+          <a:p>
+            <a:pPr algn="l"/>
+            <a:r>
+              <a:rPr sz="1200" b="0">
                 <a:solidFill>
                   <a:srgbClr val="94A3B8"/>
                 </a:solidFill>
                 <a:latin typeface="Inter"/>
               </a:rPr>
-              <a:t>WITH LIVE ZENDESK</a:t>
-            </a:r>
-          </a:p>
-        </p:txBody>
-      </p:sp>
-      <p:sp>
-        <p:nvSpPr>
-          <p:cNvPr id="11" name="TextBox 10"/>
-          <p:cNvSpPr txBox="1"/>
-          <p:nvPr/>
-        </p:nvSpPr>
-        <p:spPr>
-          <a:xfrm>
-            <a:off x="4544568" y="2514600"/>
-            <a:ext cx="2980944" cy="640080"/>
-          </a:xfrm>
-          <a:prstGeom prst="rect">
-            <a:avLst/>
-          </a:prstGeom>
-          <a:noFill/>
-        </p:spPr>
-        <p:txBody>
-          <a:bodyPr wrap="square" lIns="0" rIns="0" tIns="0" bIns="0" anchor="t">
-            <a:spAutoFit/>
-          </a:bodyPr>
-          <a:lstStyle/>
-          <a:p>
-            <a:pPr algn="l"/>
-            <a:r>
-              <a:rPr sz="3600" b="1">
-                <a:solidFill>
-                  <a:srgbClr val="F8FAFC"/>
-                </a:solidFill>
-                <a:latin typeface="DM Sans"/>
-              </a:rPr>
-              <a:t>$3,500</a:t>
-            </a:r>
-          </a:p>
-        </p:txBody>
-      </p:sp>
-      <p:sp>
-        <p:nvSpPr>
-          <p:cNvPr id="12" name="TextBox 11"/>
-          <p:cNvSpPr txBox="1"/>
-          <p:nvPr/>
-        </p:nvSpPr>
-        <p:spPr>
-          <a:xfrm>
-            <a:off x="4544568" y="3246120"/>
-            <a:ext cx="2980944" cy="868680"/>
-          </a:xfrm>
-          <a:prstGeom prst="rect">
-            <a:avLst/>
-          </a:prstGeom>
-          <a:noFill/>
-        </p:spPr>
-        <p:txBody>
-          <a:bodyPr wrap="square" lIns="0" rIns="0" tIns="0" bIns="0" anchor="t">
-            <a:spAutoFit/>
-          </a:bodyPr>
-          <a:lstStyle/>
-          <a:p>
-            <a:pPr algn="l"/>
-            <a:r>
-              <a:rPr sz="1200" b="0">
-                <a:solidFill>
-                  <a:srgbClr val="94A3B8"/>
-                </a:solidFill>
-                <a:latin typeface="Inter"/>
-              </a:rPr>
-              <a:t>Everything above plus real Zendesk ticket creation, live chat handoff, and setup guide</a:t>
-            </a:r>
-          </a:p>
-        </p:txBody>
-      </p:sp>
-      <p:sp>
-        <p:nvSpPr>
-          <p:cNvPr id="13" name="Rectangle 12"/>
+              <a:t>Primary developer on a React + Python platform serving 600 users/month. Became sole developer and SME within months. Fixed incidents in under 10 minutes. 60,000+ LOC.</a:t>
+            </a:r>
+          </a:p>
+        </p:txBody>
+      </p:sp>
+      <p:sp>
+        <p:nvSpPr>
+          <p:cNvPr id="9" name="Rectangle 8"/>
           <p:cNvSpPr/>
           <p:nvPr/>
         </p:nvSpPr>
         <p:spPr>
           <a:xfrm>
-            <a:off x="8046720" y="1920240"/>
-            <a:ext cx="3383280" cy="2286000"/>
+            <a:off x="6492240" y="2514600"/>
+            <a:ext cx="5212080" cy="1508760"/>
           </a:xfrm>
           <a:prstGeom prst="rect">
             <a:avLst/>
@@ -8219,124 +8154,90 @@
           <a:lstStyle/>
           <a:p>
             <a:pPr algn="ctr"/>
-          </a:p>
-        </p:txBody>
-      </p:sp>
-      <p:sp>
-        <p:nvSpPr>
-          <p:cNvPr id="14" name="TextBox 13"/>
-          <p:cNvSpPr txBox="1"/>
-          <p:nvPr/>
-        </p:nvSpPr>
-        <p:spPr>
-          <a:xfrm>
-            <a:off x="8247888" y="2103120"/>
-            <a:ext cx="2980944" cy="274320"/>
-          </a:xfrm>
-          <a:prstGeom prst="rect">
-            <a:avLst/>
-          </a:prstGeom>
-          <a:noFill/>
-        </p:spPr>
-        <p:txBody>
-          <a:bodyPr wrap="square" lIns="0" rIns="0" tIns="0" bIns="0" anchor="t">
-            <a:spAutoFit/>
-          </a:bodyPr>
-          <a:lstStyle/>
-          <a:p>
-            <a:pPr algn="l"/>
-            <a:r>
-              <a:rPr sz="1000" b="1">
+            <a:endParaRPr/>
+          </a:p>
+        </p:txBody>
+      </p:sp>
+      <p:sp>
+        <p:nvSpPr>
+          <p:cNvPr id="10" name="TextBox 9"/>
+          <p:cNvSpPr txBox="1"/>
+          <p:nvPr/>
+        </p:nvSpPr>
+        <p:spPr>
+          <a:xfrm>
+            <a:off x="6675120" y="2679192"/>
+            <a:ext cx="4846320" cy="320040"/>
+          </a:xfrm>
+          <a:prstGeom prst="rect">
+            <a:avLst/>
+          </a:prstGeom>
+          <a:noFill/>
+        </p:spPr>
+        <p:txBody>
+          <a:bodyPr wrap="square" lIns="0" tIns="0" rIns="0" bIns="0" anchor="t">
+            <a:spAutoFit/>
+          </a:bodyPr>
+          <a:lstStyle/>
+          <a:p>
+            <a:pPr algn="l"/>
+            <a:r>
+              <a:rPr sz="1400" b="1">
+                <a:solidFill>
+                  <a:srgbClr val="F8FAFC"/>
+                </a:solidFill>
+                <a:latin typeface="DM Sans"/>
+              </a:rPr>
+              <a:t>Azure Cloud Migration</a:t>
+            </a:r>
+          </a:p>
+        </p:txBody>
+      </p:sp>
+      <p:sp>
+        <p:nvSpPr>
+          <p:cNvPr id="11" name="TextBox 10"/>
+          <p:cNvSpPr txBox="1"/>
+          <p:nvPr/>
+        </p:nvSpPr>
+        <p:spPr>
+          <a:xfrm>
+            <a:off x="6675120" y="3063240"/>
+            <a:ext cx="4846320" cy="822960"/>
+          </a:xfrm>
+          <a:prstGeom prst="rect">
+            <a:avLst/>
+          </a:prstGeom>
+          <a:noFill/>
+        </p:spPr>
+        <p:txBody>
+          <a:bodyPr wrap="square" lIns="0" tIns="0" rIns="0" bIns="0" anchor="t">
+            <a:spAutoFit/>
+          </a:bodyPr>
+          <a:lstStyle/>
+          <a:p>
+            <a:pPr algn="l"/>
+            <a:r>
+              <a:rPr sz="1200" b="0">
                 <a:solidFill>
                   <a:srgbClr val="94A3B8"/>
                 </a:solidFill>
                 <a:latin typeface="Inter"/>
               </a:rPr>
-              <a:t>FULL PRODUCTION</a:t>
-            </a:r>
-          </a:p>
-        </p:txBody>
-      </p:sp>
-      <p:sp>
-        <p:nvSpPr>
-          <p:cNvPr id="15" name="TextBox 14"/>
-          <p:cNvSpPr txBox="1"/>
-          <p:nvPr/>
-        </p:nvSpPr>
-        <p:spPr>
-          <a:xfrm>
-            <a:off x="8247888" y="2514600"/>
-            <a:ext cx="2980944" cy="640080"/>
-          </a:xfrm>
-          <a:prstGeom prst="rect">
-            <a:avLst/>
-          </a:prstGeom>
-          <a:noFill/>
-        </p:spPr>
-        <p:txBody>
-          <a:bodyPr wrap="square" lIns="0" rIns="0" tIns="0" bIns="0" anchor="t">
-            <a:spAutoFit/>
-          </a:bodyPr>
-          <a:lstStyle/>
-          <a:p>
-            <a:pPr algn="l"/>
-            <a:r>
-              <a:rPr sz="3600" b="1">
-                <a:solidFill>
-                  <a:srgbClr val="F8FAFC"/>
-                </a:solidFill>
-                <a:latin typeface="DM Sans"/>
-              </a:rPr>
-              <a:t>$4,500</a:t>
-            </a:r>
-          </a:p>
-        </p:txBody>
-      </p:sp>
-      <p:sp>
-        <p:nvSpPr>
-          <p:cNvPr id="16" name="TextBox 15"/>
-          <p:cNvSpPr txBox="1"/>
-          <p:nvPr/>
-        </p:nvSpPr>
-        <p:spPr>
-          <a:xfrm>
-            <a:off x="8247888" y="3246120"/>
-            <a:ext cx="2980944" cy="868680"/>
-          </a:xfrm>
-          <a:prstGeom prst="rect">
-            <a:avLst/>
-          </a:prstGeom>
-          <a:noFill/>
-        </p:spPr>
-        <p:txBody>
-          <a:bodyPr wrap="square" lIns="0" rIns="0" tIns="0" bIns="0" anchor="t">
-            <a:spAutoFit/>
-          </a:bodyPr>
-          <a:lstStyle/>
-          <a:p>
-            <a:pPr algn="l"/>
-            <a:r>
-              <a:rPr sz="1200" b="0">
-                <a:solidFill>
-                  <a:srgbClr val="94A3B8"/>
-                </a:solidFill>
-                <a:latin typeface="Inter"/>
-              </a:rPr>
-              <a:t>Everything above plus multi-language KB, Zendesk app config, custom branding, post-launch support</a:t>
-            </a:r>
-          </a:p>
-        </p:txBody>
-      </p:sp>
-      <p:sp>
-        <p:nvSpPr>
-          <p:cNvPr id="17" name="Rectangle 16"/>
+              <a:t>Led a 6-month migration to Azure as the project's main representative, among the first internal apps the bank migrated.</a:t>
+            </a:r>
+          </a:p>
+        </p:txBody>
+      </p:sp>
+      <p:sp>
+        <p:nvSpPr>
+          <p:cNvPr id="12" name="Rectangle 11"/>
           <p:cNvSpPr/>
           <p:nvPr/>
         </p:nvSpPr>
         <p:spPr>
           <a:xfrm>
-            <a:off x="640080" y="4434840"/>
-            <a:ext cx="10881360" cy="2057400"/>
+            <a:off x="822960" y="4251960"/>
+            <a:ext cx="5212080" cy="1508760"/>
           </a:xfrm>
           <a:prstGeom prst="rect">
             <a:avLst/>
@@ -8370,27 +8271,63 @@
           <a:lstStyle/>
           <a:p>
             <a:pPr algn="ctr"/>
-          </a:p>
-        </p:txBody>
-      </p:sp>
-      <p:sp>
-        <p:nvSpPr>
-          <p:cNvPr id="18" name="TextBox 17"/>
-          <p:cNvSpPr txBox="1"/>
-          <p:nvPr/>
-        </p:nvSpPr>
-        <p:spPr>
-          <a:xfrm>
-            <a:off x="822960" y="4526280"/>
-            <a:ext cx="8686800" cy="256032"/>
-          </a:xfrm>
-          <a:prstGeom prst="rect">
-            <a:avLst/>
-          </a:prstGeom>
-          <a:noFill/>
-        </p:spPr>
-        <p:txBody>
-          <a:bodyPr wrap="square" lIns="0" rIns="0" tIns="0" bIns="0" anchor="t">
+            <a:endParaRPr/>
+          </a:p>
+        </p:txBody>
+      </p:sp>
+      <p:sp>
+        <p:nvSpPr>
+          <p:cNvPr id="13" name="TextBox 12"/>
+          <p:cNvSpPr txBox="1"/>
+          <p:nvPr/>
+        </p:nvSpPr>
+        <p:spPr>
+          <a:xfrm>
+            <a:off x="1005840" y="4416552"/>
+            <a:ext cx="4846320" cy="320040"/>
+          </a:xfrm>
+          <a:prstGeom prst="rect">
+            <a:avLst/>
+          </a:prstGeom>
+          <a:noFill/>
+        </p:spPr>
+        <p:txBody>
+          <a:bodyPr wrap="square" lIns="0" tIns="0" rIns="0" bIns="0" anchor="t">
+            <a:spAutoFit/>
+          </a:bodyPr>
+          <a:lstStyle/>
+          <a:p>
+            <a:pPr algn="l"/>
+            <a:r>
+              <a:rPr sz="1400" b="1">
+                <a:solidFill>
+                  <a:srgbClr val="F8FAFC"/>
+                </a:solidFill>
+                <a:latin typeface="DM Sans"/>
+              </a:rPr>
+              <a:t>Optum (current)</a:t>
+            </a:r>
+          </a:p>
+        </p:txBody>
+      </p:sp>
+      <p:sp>
+        <p:nvSpPr>
+          <p:cNvPr id="14" name="TextBox 13"/>
+          <p:cNvSpPr txBox="1"/>
+          <p:nvPr/>
+        </p:nvSpPr>
+        <p:spPr>
+          <a:xfrm>
+            <a:off x="1005840" y="4800600"/>
+            <a:ext cx="4846320" cy="822960"/>
+          </a:xfrm>
+          <a:prstGeom prst="rect">
+            <a:avLst/>
+          </a:prstGeom>
+          <a:noFill/>
+        </p:spPr>
+        <p:txBody>
+          <a:bodyPr wrap="square" lIns="0" tIns="0" rIns="0" bIns="0" anchor="t">
             <a:spAutoFit/>
           </a:bodyPr>
           <a:lstStyle/>
@@ -8399,69 +8336,36 @@
             <a:r>
               <a:rPr sz="1200" b="0">
                 <a:solidFill>
-                  <a:srgbClr val="CBD5E1"/>
+                  <a:srgbClr val="94A3B8"/>
                 </a:solidFill>
                 <a:latin typeface="Inter"/>
               </a:rPr>
-              <a:t>Architecture + knowledge base setup</a:t>
-            </a:r>
-          </a:p>
-        </p:txBody>
-      </p:sp>
-      <p:sp>
-        <p:nvSpPr>
-          <p:cNvPr id="19" name="TextBox 18"/>
-          <p:cNvSpPr txBox="1"/>
-          <p:nvPr/>
-        </p:nvSpPr>
-        <p:spPr>
-          <a:xfrm>
-            <a:off x="10058400" y="4526280"/>
-            <a:ext cx="1280160" cy="256032"/>
-          </a:xfrm>
-          <a:prstGeom prst="rect">
-            <a:avLst/>
-          </a:prstGeom>
-          <a:noFill/>
-        </p:spPr>
-        <p:txBody>
-          <a:bodyPr wrap="square" lIns="0" rIns="0" tIns="0" bIns="0" anchor="t">
-            <a:spAutoFit/>
-          </a:bodyPr>
-          <a:lstStyle/>
-          <a:p>
-            <a:pPr algn="r"/>
-            <a:r>
-              <a:rPr sz="1200" b="1">
-                <a:solidFill>
-                  <a:srgbClr val="10B981"/>
-                </a:solidFill>
-                <a:latin typeface="Inter"/>
-              </a:rPr>
-              <a:t>1 day</a:t>
-            </a:r>
-          </a:p>
-        </p:txBody>
-      </p:sp>
-      <p:sp>
-        <p:nvSpPr>
-          <p:cNvPr id="20" name="Rectangle 19"/>
+              <a:t>Angular + .NET + PostgreSQL on a large Agile team. 150+ story points delivered. Team's go-to for AI-assisted development. Contract won April 2026.</a:t>
+            </a:r>
+          </a:p>
+        </p:txBody>
+      </p:sp>
+      <p:sp>
+        <p:nvSpPr>
+          <p:cNvPr id="15" name="Rectangle 14"/>
           <p:cNvSpPr/>
           <p:nvPr/>
         </p:nvSpPr>
         <p:spPr>
           <a:xfrm>
-            <a:off x="640080" y="4791456"/>
-            <a:ext cx="10881360" cy="310896"/>
+            <a:off x="6492240" y="4251960"/>
+            <a:ext cx="5212080" cy="1508760"/>
           </a:xfrm>
           <a:prstGeom prst="rect">
             <a:avLst/>
           </a:prstGeom>
           <a:solidFill>
-            <a:srgbClr val="273549"/>
+            <a:srgbClr val="1E293B"/>
           </a:solidFill>
-          <a:ln>
-            <a:noFill/>
+          <a:ln w="9525">
+            <a:solidFill>
+              <a:srgbClr val="334155"/>
+            </a:solidFill>
           </a:ln>
           <a:effectLst/>
         </p:spPr>
@@ -8484,27 +8388,63 @@
           <a:lstStyle/>
           <a:p>
             <a:pPr algn="ctr"/>
-          </a:p>
-        </p:txBody>
-      </p:sp>
-      <p:sp>
-        <p:nvSpPr>
-          <p:cNvPr id="21" name="TextBox 20"/>
-          <p:cNvSpPr txBox="1"/>
-          <p:nvPr/>
-        </p:nvSpPr>
-        <p:spPr>
-          <a:xfrm>
-            <a:off x="822960" y="4837176"/>
-            <a:ext cx="8686800" cy="256032"/>
-          </a:xfrm>
-          <a:prstGeom prst="rect">
-            <a:avLst/>
-          </a:prstGeom>
-          <a:noFill/>
-        </p:spPr>
-        <p:txBody>
-          <a:bodyPr wrap="square" lIns="0" rIns="0" tIns="0" bIns="0" anchor="t">
+            <a:endParaRPr/>
+          </a:p>
+        </p:txBody>
+      </p:sp>
+      <p:sp>
+        <p:nvSpPr>
+          <p:cNvPr id="16" name="TextBox 15"/>
+          <p:cNvSpPr txBox="1"/>
+          <p:nvPr/>
+        </p:nvSpPr>
+        <p:spPr>
+          <a:xfrm>
+            <a:off x="6675120" y="4416552"/>
+            <a:ext cx="4846320" cy="320040"/>
+          </a:xfrm>
+          <a:prstGeom prst="rect">
+            <a:avLst/>
+          </a:prstGeom>
+          <a:noFill/>
+        </p:spPr>
+        <p:txBody>
+          <a:bodyPr wrap="square" lIns="0" tIns="0" rIns="0" bIns="0" anchor="t">
+            <a:spAutoFit/>
+          </a:bodyPr>
+          <a:lstStyle/>
+          <a:p>
+            <a:pPr algn="l"/>
+            <a:r>
+              <a:rPr sz="1400" b="1">
+                <a:solidFill>
+                  <a:srgbClr val="F8FAFC"/>
+                </a:solidFill>
+                <a:latin typeface="DM Sans"/>
+              </a:rPr>
+              <a:t>AI delivery, daily</a:t>
+            </a:r>
+          </a:p>
+        </p:txBody>
+      </p:sp>
+      <p:sp>
+        <p:nvSpPr>
+          <p:cNvPr id="17" name="TextBox 16"/>
+          <p:cNvSpPr txBox="1"/>
+          <p:nvPr/>
+        </p:nvSpPr>
+        <p:spPr>
+          <a:xfrm>
+            <a:off x="6675120" y="4800600"/>
+            <a:ext cx="4846320" cy="822960"/>
+          </a:xfrm>
+          <a:prstGeom prst="rect">
+            <a:avLst/>
+          </a:prstGeom>
+          <a:noFill/>
+        </p:spPr>
+        <p:txBody>
+          <a:bodyPr wrap="square" lIns="0" tIns="0" rIns="0" bIns="0" anchor="t">
             <a:spAutoFit/>
           </a:bodyPr>
           <a:lstStyle/>
@@ -8513,421 +8453,18 @@
             <a:r>
               <a:rPr sz="1200" b="0">
                 <a:solidFill>
-                  <a:srgbClr val="CBD5E1"/>
+                  <a:srgbClr val="94A3B8"/>
                 </a:solidFill>
                 <a:latin typeface="Inter"/>
               </a:rPr>
-              <a:t>Core chatbot + RAG + in-browser LLM</a:t>
-            </a:r>
-          </a:p>
-        </p:txBody>
-      </p:sp>
-      <p:sp>
-        <p:nvSpPr>
-          <p:cNvPr id="22" name="TextBox 21"/>
-          <p:cNvSpPr txBox="1"/>
-          <p:nvPr/>
-        </p:nvSpPr>
-        <p:spPr>
-          <a:xfrm>
-            <a:off x="10058400" y="4837176"/>
-            <a:ext cx="1280160" cy="256032"/>
-          </a:xfrm>
-          <a:prstGeom prst="rect">
-            <a:avLst/>
-          </a:prstGeom>
-          <a:noFill/>
-        </p:spPr>
-        <p:txBody>
-          <a:bodyPr wrap="square" lIns="0" rIns="0" tIns="0" bIns="0" anchor="t">
-            <a:spAutoFit/>
-          </a:bodyPr>
-          <a:lstStyle/>
-          <a:p>
-            <a:pPr algn="r"/>
-            <a:r>
-              <a:rPr sz="1200" b="1">
-                <a:solidFill>
-                  <a:srgbClr val="10B981"/>
-                </a:solidFill>
-                <a:latin typeface="Inter"/>
-              </a:rPr>
-              <a:t>3 days</a:t>
-            </a:r>
-          </a:p>
-        </p:txBody>
-      </p:sp>
-      <p:sp>
-        <p:nvSpPr>
-          <p:cNvPr id="23" name="TextBox 22"/>
-          <p:cNvSpPr txBox="1"/>
-          <p:nvPr/>
-        </p:nvSpPr>
-        <p:spPr>
-          <a:xfrm>
-            <a:off x="822960" y="5148072"/>
-            <a:ext cx="8686800" cy="256032"/>
-          </a:xfrm>
-          <a:prstGeom prst="rect">
-            <a:avLst/>
-          </a:prstGeom>
-          <a:noFill/>
-        </p:spPr>
-        <p:txBody>
-          <a:bodyPr wrap="square" lIns="0" rIns="0" tIns="0" bIns="0" anchor="t">
-            <a:spAutoFit/>
-          </a:bodyPr>
-          <a:lstStyle/>
-          <a:p>
-            <a:pPr algn="l"/>
-            <a:r>
-              <a:rPr sz="1200" b="0">
-                <a:solidFill>
-                  <a:srgbClr val="CBD5E1"/>
-                </a:solidFill>
-                <a:latin typeface="Inter"/>
-              </a:rPr>
-              <a:t>Order lookup + escalation flow</a:t>
-            </a:r>
-          </a:p>
-        </p:txBody>
-      </p:sp>
-      <p:sp>
-        <p:nvSpPr>
-          <p:cNvPr id="24" name="TextBox 23"/>
-          <p:cNvSpPr txBox="1"/>
-          <p:nvPr/>
-        </p:nvSpPr>
-        <p:spPr>
-          <a:xfrm>
-            <a:off x="10058400" y="5148072"/>
-            <a:ext cx="1280160" cy="256032"/>
-          </a:xfrm>
-          <a:prstGeom prst="rect">
-            <a:avLst/>
-          </a:prstGeom>
-          <a:noFill/>
-        </p:spPr>
-        <p:txBody>
-          <a:bodyPr wrap="square" lIns="0" rIns="0" tIns="0" bIns="0" anchor="t">
-            <a:spAutoFit/>
-          </a:bodyPr>
-          <a:lstStyle/>
-          <a:p>
-            <a:pPr algn="r"/>
-            <a:r>
-              <a:rPr sz="1200" b="1">
-                <a:solidFill>
-                  <a:srgbClr val="10B981"/>
-                </a:solidFill>
-                <a:latin typeface="Inter"/>
-              </a:rPr>
-              <a:t>1 day</a:t>
-            </a:r>
-          </a:p>
-        </p:txBody>
-      </p:sp>
-      <p:sp>
-        <p:nvSpPr>
-          <p:cNvPr id="25" name="Rectangle 24"/>
-          <p:cNvSpPr/>
-          <p:nvPr/>
-        </p:nvSpPr>
-        <p:spPr>
-          <a:xfrm>
-            <a:off x="640080" y="5413248"/>
-            <a:ext cx="10881360" cy="310896"/>
-          </a:xfrm>
-          <a:prstGeom prst="rect">
-            <a:avLst/>
-          </a:prstGeom>
-          <a:solidFill>
-            <a:srgbClr val="273549"/>
-          </a:solidFill>
-          <a:ln>
-            <a:noFill/>
-          </a:ln>
-          <a:effectLst/>
-        </p:spPr>
-        <p:style>
-          <a:lnRef idx="1">
-            <a:schemeClr val="accent1"/>
-          </a:lnRef>
-          <a:fillRef idx="3">
-            <a:schemeClr val="accent1"/>
-          </a:fillRef>
-          <a:effectRef idx="2">
-            <a:schemeClr val="accent1"/>
-          </a:effectRef>
-          <a:fontRef idx="minor">
-            <a:schemeClr val="lt1"/>
-          </a:fontRef>
-        </p:style>
-        <p:txBody>
-          <a:bodyPr rtlCol="0" anchor="ctr"/>
-          <a:lstStyle/>
-          <a:p>
-            <a:pPr algn="ctr"/>
-          </a:p>
-        </p:txBody>
-      </p:sp>
-      <p:sp>
-        <p:nvSpPr>
-          <p:cNvPr id="26" name="TextBox 25"/>
-          <p:cNvSpPr txBox="1"/>
-          <p:nvPr/>
-        </p:nvSpPr>
-        <p:spPr>
-          <a:xfrm>
-            <a:off x="822960" y="5458968"/>
-            <a:ext cx="8686800" cy="256032"/>
-          </a:xfrm>
-          <a:prstGeom prst="rect">
-            <a:avLst/>
-          </a:prstGeom>
-          <a:noFill/>
-        </p:spPr>
-        <p:txBody>
-          <a:bodyPr wrap="square" lIns="0" rIns="0" tIns="0" bIns="0" anchor="t">
-            <a:spAutoFit/>
-          </a:bodyPr>
-          <a:lstStyle/>
-          <a:p>
-            <a:pPr algn="l"/>
-            <a:r>
-              <a:rPr sz="1200" b="0">
-                <a:solidFill>
-                  <a:srgbClr val="CBD5E1"/>
-                </a:solidFill>
-                <a:latin typeface="Inter"/>
-              </a:rPr>
-              <a:t>Admin panel + analytics</a:t>
-            </a:r>
-          </a:p>
-        </p:txBody>
-      </p:sp>
-      <p:sp>
-        <p:nvSpPr>
-          <p:cNvPr id="27" name="TextBox 26"/>
-          <p:cNvSpPr txBox="1"/>
-          <p:nvPr/>
-        </p:nvSpPr>
-        <p:spPr>
-          <a:xfrm>
-            <a:off x="10058400" y="5458968"/>
-            <a:ext cx="1280160" cy="256032"/>
-          </a:xfrm>
-          <a:prstGeom prst="rect">
-            <a:avLst/>
-          </a:prstGeom>
-          <a:noFill/>
-        </p:spPr>
-        <p:txBody>
-          <a:bodyPr wrap="square" lIns="0" rIns="0" tIns="0" bIns="0" anchor="t">
-            <a:spAutoFit/>
-          </a:bodyPr>
-          <a:lstStyle/>
-          <a:p>
-            <a:pPr algn="r"/>
-            <a:r>
-              <a:rPr sz="1200" b="1">
-                <a:solidFill>
-                  <a:srgbClr val="10B981"/>
-                </a:solidFill>
-                <a:latin typeface="Inter"/>
-              </a:rPr>
-              <a:t>1 day</a:t>
-            </a:r>
-          </a:p>
-        </p:txBody>
-      </p:sp>
-      <p:sp>
-        <p:nvSpPr>
-          <p:cNvPr id="28" name="TextBox 27"/>
-          <p:cNvSpPr txBox="1"/>
-          <p:nvPr/>
-        </p:nvSpPr>
-        <p:spPr>
-          <a:xfrm>
-            <a:off x="822960" y="5769864"/>
-            <a:ext cx="8686800" cy="256032"/>
-          </a:xfrm>
-          <a:prstGeom prst="rect">
-            <a:avLst/>
-          </a:prstGeom>
-          <a:noFill/>
-        </p:spPr>
-        <p:txBody>
-          <a:bodyPr wrap="square" lIns="0" rIns="0" tIns="0" bIns="0" anchor="t">
-            <a:spAutoFit/>
-          </a:bodyPr>
-          <a:lstStyle/>
-          <a:p>
-            <a:pPr algn="l"/>
-            <a:r>
-              <a:rPr sz="1200" b="0">
-                <a:solidFill>
-                  <a:srgbClr val="CBD5E1"/>
-                </a:solidFill>
-                <a:latin typeface="Inter"/>
-              </a:rPr>
-              <a:t>Zendesk integration + docs</a:t>
-            </a:r>
-          </a:p>
-        </p:txBody>
-      </p:sp>
-      <p:sp>
-        <p:nvSpPr>
-          <p:cNvPr id="29" name="TextBox 28"/>
-          <p:cNvSpPr txBox="1"/>
-          <p:nvPr/>
-        </p:nvSpPr>
-        <p:spPr>
-          <a:xfrm>
-            <a:off x="10058400" y="5769864"/>
-            <a:ext cx="1280160" cy="256032"/>
-          </a:xfrm>
-          <a:prstGeom prst="rect">
-            <a:avLst/>
-          </a:prstGeom>
-          <a:noFill/>
-        </p:spPr>
-        <p:txBody>
-          <a:bodyPr wrap="square" lIns="0" rIns="0" tIns="0" bIns="0" anchor="t">
-            <a:spAutoFit/>
-          </a:bodyPr>
-          <a:lstStyle/>
-          <a:p>
-            <a:pPr algn="r"/>
-            <a:r>
-              <a:rPr sz="1200" b="1">
-                <a:solidFill>
-                  <a:srgbClr val="10B981"/>
-                </a:solidFill>
-                <a:latin typeface="Inter"/>
-              </a:rPr>
-              <a:t>0.5 days</a:t>
-            </a:r>
-          </a:p>
-        </p:txBody>
-      </p:sp>
-      <p:sp>
-        <p:nvSpPr>
-          <p:cNvPr id="30" name="Rectangle 29"/>
-          <p:cNvSpPr/>
-          <p:nvPr/>
-        </p:nvSpPr>
-        <p:spPr>
-          <a:xfrm>
-            <a:off x="640080" y="6035040"/>
-            <a:ext cx="10881360" cy="310896"/>
-          </a:xfrm>
-          <a:prstGeom prst="rect">
-            <a:avLst/>
-          </a:prstGeom>
-          <a:solidFill>
-            <a:srgbClr val="273549"/>
-          </a:solidFill>
-          <a:ln>
-            <a:noFill/>
-          </a:ln>
-          <a:effectLst/>
-        </p:spPr>
-        <p:style>
-          <a:lnRef idx="1">
-            <a:schemeClr val="accent1"/>
-          </a:lnRef>
-          <a:fillRef idx="3">
-            <a:schemeClr val="accent1"/>
-          </a:fillRef>
-          <a:effectRef idx="2">
-            <a:schemeClr val="accent1"/>
-          </a:effectRef>
-          <a:fontRef idx="minor">
-            <a:schemeClr val="lt1"/>
-          </a:fontRef>
-        </p:style>
-        <p:txBody>
-          <a:bodyPr rtlCol="0" anchor="ctr"/>
-          <a:lstStyle/>
-          <a:p>
-            <a:pPr algn="ctr"/>
-          </a:p>
-        </p:txBody>
-      </p:sp>
-      <p:sp>
-        <p:nvSpPr>
-          <p:cNvPr id="31" name="TextBox 30"/>
-          <p:cNvSpPr txBox="1"/>
-          <p:nvPr/>
-        </p:nvSpPr>
-        <p:spPr>
-          <a:xfrm>
-            <a:off x="822960" y="6080760"/>
-            <a:ext cx="8686800" cy="256032"/>
-          </a:xfrm>
-          <a:prstGeom prst="rect">
-            <a:avLst/>
-          </a:prstGeom>
-          <a:noFill/>
-        </p:spPr>
-        <p:txBody>
-          <a:bodyPr wrap="square" lIns="0" rIns="0" tIns="0" bIns="0" anchor="t">
-            <a:spAutoFit/>
-          </a:bodyPr>
-          <a:lstStyle/>
-          <a:p>
-            <a:pPr algn="l"/>
-            <a:r>
-              <a:rPr sz="1200" b="0">
-                <a:solidFill>
-                  <a:srgbClr val="CBD5E1"/>
-                </a:solidFill>
-                <a:latin typeface="Inter"/>
-              </a:rPr>
-              <a:t>QA + polish + embed package</a:t>
-            </a:r>
-          </a:p>
-        </p:txBody>
-      </p:sp>
-      <p:sp>
-        <p:nvSpPr>
-          <p:cNvPr id="32" name="TextBox 31"/>
-          <p:cNvSpPr txBox="1"/>
-          <p:nvPr/>
-        </p:nvSpPr>
-        <p:spPr>
-          <a:xfrm>
-            <a:off x="10058400" y="6080760"/>
-            <a:ext cx="1280160" cy="256032"/>
-          </a:xfrm>
-          <a:prstGeom prst="rect">
-            <a:avLst/>
-          </a:prstGeom>
-          <a:noFill/>
-        </p:spPr>
-        <p:txBody>
-          <a:bodyPr wrap="square" lIns="0" rIns="0" tIns="0" bIns="0" anchor="t">
-            <a:spAutoFit/>
-          </a:bodyPr>
-          <a:lstStyle/>
-          <a:p>
-            <a:pPr algn="r"/>
-            <a:r>
-              <a:rPr sz="1200" b="1">
-                <a:solidFill>
-                  <a:srgbClr val="10B981"/>
-                </a:solidFill>
-                <a:latin typeface="Inter"/>
-              </a:rPr>
-              <a:t>1 day</a:t>
-            </a:r>
-          </a:p>
-        </p:txBody>
-      </p:sp>
-      <p:sp>
-        <p:nvSpPr>
-          <p:cNvPr id="33" name="TextBox 32"/>
+              <a:t>Built this demo's in-browser RAG chatbot in a single session using Transformers.js, the same stack I would use on your production build.</a:t>
+            </a:r>
+          </a:p>
+        </p:txBody>
+      </p:sp>
+      <p:sp>
+        <p:nvSpPr>
+          <p:cNvPr id="18" name="TextBox 17"/>
           <p:cNvSpPr txBox="1"/>
           <p:nvPr/>
         </p:nvSpPr>
@@ -8942,7 +8479,7 @@
           <a:noFill/>
         </p:spPr>
         <p:txBody>
-          <a:bodyPr wrap="square" lIns="0" rIns="0" tIns="0" bIns="0" anchor="t">
+          <a:bodyPr wrap="square" lIns="0" tIns="0" rIns="0" bIns="0" anchor="t">
             <a:spAutoFit/>
           </a:bodyPr>
           <a:lstStyle/>
@@ -8962,7 +8499,7 @@
       </p:sp>
       <p:sp>
         <p:nvSpPr>
-          <p:cNvPr id="34" name="TextBox 33"/>
+          <p:cNvPr id="19" name="TextBox 18"/>
           <p:cNvSpPr txBox="1"/>
           <p:nvPr/>
         </p:nvSpPr>
@@ -8977,7 +8514,7 @@
           <a:noFill/>
         </p:spPr>
         <p:txBody>
-          <a:bodyPr wrap="square" lIns="0" rIns="0" tIns="0" bIns="0" anchor="t">
+          <a:bodyPr wrap="square" lIns="0" tIns="0" rIns="0" bIns="0" anchor="t">
             <a:spAutoFit/>
           </a:bodyPr>
           <a:lstStyle/>
@@ -8990,7 +8527,7 @@
                 </a:solidFill>
                 <a:latin typeface="Inter"/>
               </a:rPr>
-              <a:t>7 / 9</a:t>
+              <a:t>8 / 9</a:t>
             </a:r>
           </a:p>
         </p:txBody>
@@ -9004,7 +8541,7 @@
 </file>
 
 <file path=ppt/slides/slide8.xml><?xml version="1.0" encoding="utf-8"?>
-<p:sld xmlns:a="http://schemas.openxmlformats.org/drawingml/2006/main" xmlns:p="http://schemas.openxmlformats.org/presentationml/2006/main" xmlns:r="http://schemas.openxmlformats.org/officeDocument/2006/relationships">
+<p:sld xmlns:a="http://schemas.openxmlformats.org/drawingml/2006/main" xmlns:r="http://schemas.openxmlformats.org/officeDocument/2006/relationships" xmlns:p="http://schemas.openxmlformats.org/presentationml/2006/main">
   <p:cSld>
     <p:spTree>
       <p:nvGrpSpPr>
@@ -9012,7 +8549,14 @@
         <p:cNvGrpSpPr/>
         <p:nvPr/>
       </p:nvGrpSpPr>
-      <p:grpSpPr/>
+      <p:grpSpPr>
+        <a:xfrm>
+          <a:off x="0" y="0"/>
+          <a:ext cx="0" cy="0"/>
+          <a:chOff x="0" y="0"/>
+          <a:chExt cx="0" cy="0"/>
+        </a:xfrm>
+      </p:grpSpPr>
       <p:sp>
         <p:nvSpPr>
           <p:cNvPr id="2" name="Rectangle 1"/>
@@ -9054,707 +8598,7 @@
           <a:lstStyle/>
           <a:p>
             <a:pPr algn="ctr"/>
-          </a:p>
-        </p:txBody>
-      </p:sp>
-      <p:sp>
-        <p:nvSpPr>
-          <p:cNvPr id="3" name="TextBox 2"/>
-          <p:cNvSpPr txBox="1"/>
-          <p:nvPr/>
-        </p:nvSpPr>
-        <p:spPr>
-          <a:xfrm>
-            <a:off x="822960" y="502920"/>
-            <a:ext cx="5486400" cy="256032"/>
-          </a:xfrm>
-          <a:prstGeom prst="rect">
-            <a:avLst/>
-          </a:prstGeom>
-          <a:noFill/>
-        </p:spPr>
-        <p:txBody>
-          <a:bodyPr wrap="square" lIns="0" rIns="0" tIns="0" bIns="0" anchor="t">
-            <a:spAutoFit/>
-          </a:bodyPr>
-          <a:lstStyle/>
-          <a:p>
-            <a:pPr algn="l"/>
-            <a:r>
-              <a:rPr sz="1000" b="1">
-                <a:solidFill>
-                  <a:srgbClr val="10B981"/>
-                </a:solidFill>
-                <a:latin typeface="Inter"/>
-              </a:rPr>
-              <a:t>ABOUT MICHAEL WEGTER</a:t>
-            </a:r>
-          </a:p>
-        </p:txBody>
-      </p:sp>
-      <p:sp>
-        <p:nvSpPr>
-          <p:cNvPr id="4" name="TextBox 3"/>
-          <p:cNvSpPr txBox="1"/>
-          <p:nvPr/>
-        </p:nvSpPr>
-        <p:spPr>
-          <a:xfrm>
-            <a:off x="822960" y="914400"/>
-            <a:ext cx="10058400" cy="685800"/>
-          </a:xfrm>
-          <a:prstGeom prst="rect">
-            <a:avLst/>
-          </a:prstGeom>
-          <a:noFill/>
-        </p:spPr>
-        <p:txBody>
-          <a:bodyPr wrap="square" lIns="0" rIns="0" tIns="0" bIns="0" anchor="t">
-            <a:spAutoFit/>
-          </a:bodyPr>
-          <a:lstStyle/>
-          <a:p>
-            <a:pPr algn="l"/>
-            <a:r>
-              <a:rPr sz="3200" b="1">
-                <a:solidFill>
-                  <a:srgbClr val="F8FAFC"/>
-                </a:solidFill>
-                <a:latin typeface="DM Sans"/>
-              </a:rPr>
-              <a:t>Full-stack developer, currently based in the United States</a:t>
-            </a:r>
-          </a:p>
-        </p:txBody>
-      </p:sp>
-      <p:sp>
-        <p:nvSpPr>
-          <p:cNvPr id="5" name="TextBox 4"/>
-          <p:cNvSpPr txBox="1"/>
-          <p:nvPr/>
-        </p:nvSpPr>
-        <p:spPr>
-          <a:xfrm>
-            <a:off x="822960" y="1783080"/>
-            <a:ext cx="9144000" cy="502920"/>
-          </a:xfrm>
-          <a:prstGeom prst="rect">
-            <a:avLst/>
-          </a:prstGeom>
-          <a:noFill/>
-        </p:spPr>
-        <p:txBody>
-          <a:bodyPr wrap="square" lIns="0" rIns="0" tIns="0" bIns="0" anchor="t">
-            <a:spAutoFit/>
-          </a:bodyPr>
-          <a:lstStyle/>
-          <a:p>
-            <a:pPr algn="l"/>
-            <a:r>
-              <a:rPr sz="1400" b="0">
-                <a:solidFill>
-                  <a:srgbClr val="CBD5E1"/>
-                </a:solidFill>
-                <a:latin typeface="Inter"/>
-              </a:rPr>
-              <a:t>I confirmed: I am currently based in the United States. I have built the stack this project requires and ship AI-assisted features daily.</a:t>
-            </a:r>
-          </a:p>
-        </p:txBody>
-      </p:sp>
-      <p:sp>
-        <p:nvSpPr>
-          <p:cNvPr id="6" name="Rectangle 5"/>
-          <p:cNvSpPr/>
-          <p:nvPr/>
-        </p:nvSpPr>
-        <p:spPr>
-          <a:xfrm>
-            <a:off x="822960" y="2514600"/>
-            <a:ext cx="5212080" cy="1508760"/>
-          </a:xfrm>
-          <a:prstGeom prst="rect">
-            <a:avLst/>
-          </a:prstGeom>
-          <a:solidFill>
-            <a:srgbClr val="1E293B"/>
-          </a:solidFill>
-          <a:ln w="9525">
-            <a:solidFill>
-              <a:srgbClr val="334155"/>
-            </a:solidFill>
-          </a:ln>
-          <a:effectLst/>
-        </p:spPr>
-        <p:style>
-          <a:lnRef idx="1">
-            <a:schemeClr val="accent1"/>
-          </a:lnRef>
-          <a:fillRef idx="3">
-            <a:schemeClr val="accent1"/>
-          </a:fillRef>
-          <a:effectRef idx="2">
-            <a:schemeClr val="accent1"/>
-          </a:effectRef>
-          <a:fontRef idx="minor">
-            <a:schemeClr val="lt1"/>
-          </a:fontRef>
-        </p:style>
-        <p:txBody>
-          <a:bodyPr rtlCol="0" anchor="ctr"/>
-          <a:lstStyle/>
-          <a:p>
-            <a:pPr algn="ctr"/>
-          </a:p>
-        </p:txBody>
-      </p:sp>
-      <p:sp>
-        <p:nvSpPr>
-          <p:cNvPr id="7" name="TextBox 6"/>
-          <p:cNvSpPr txBox="1"/>
-          <p:nvPr/>
-        </p:nvSpPr>
-        <p:spPr>
-          <a:xfrm>
-            <a:off x="1005840" y="2679192"/>
-            <a:ext cx="4846320" cy="320040"/>
-          </a:xfrm>
-          <a:prstGeom prst="rect">
-            <a:avLst/>
-          </a:prstGeom>
-          <a:noFill/>
-        </p:spPr>
-        <p:txBody>
-          <a:bodyPr wrap="square" lIns="0" rIns="0" tIns="0" bIns="0" anchor="t">
-            <a:spAutoFit/>
-          </a:bodyPr>
-          <a:lstStyle/>
-          <a:p>
-            <a:pPr algn="l"/>
-            <a:r>
-              <a:rPr sz="1400" b="1">
-                <a:solidFill>
-                  <a:srgbClr val="F8FAFC"/>
-                </a:solidFill>
-                <a:latin typeface="DM Sans"/>
-              </a:rPr>
-              <a:t>2.5 years at U.S. Bank</a:t>
-            </a:r>
-          </a:p>
-        </p:txBody>
-      </p:sp>
-      <p:sp>
-        <p:nvSpPr>
-          <p:cNvPr id="8" name="TextBox 7"/>
-          <p:cNvSpPr txBox="1"/>
-          <p:nvPr/>
-        </p:nvSpPr>
-        <p:spPr>
-          <a:xfrm>
-            <a:off x="1005840" y="3063240"/>
-            <a:ext cx="4846320" cy="822960"/>
-          </a:xfrm>
-          <a:prstGeom prst="rect">
-            <a:avLst/>
-          </a:prstGeom>
-          <a:noFill/>
-        </p:spPr>
-        <p:txBody>
-          <a:bodyPr wrap="square" lIns="0" rIns="0" tIns="0" bIns="0" anchor="t">
-            <a:spAutoFit/>
-          </a:bodyPr>
-          <a:lstStyle/>
-          <a:p>
-            <a:pPr algn="l"/>
-            <a:r>
-              <a:rPr sz="1200" b="0">
-                <a:solidFill>
-                  <a:srgbClr val="94A3B8"/>
-                </a:solidFill>
-                <a:latin typeface="Inter"/>
-              </a:rPr>
-              <a:t>Primary developer on a React + Python platform serving 600 users/month. Became sole developer and SME within months. Fixed incidents in under 10 minutes. 60,000+ LOC.</a:t>
-            </a:r>
-          </a:p>
-        </p:txBody>
-      </p:sp>
-      <p:sp>
-        <p:nvSpPr>
-          <p:cNvPr id="9" name="Rectangle 8"/>
-          <p:cNvSpPr/>
-          <p:nvPr/>
-        </p:nvSpPr>
-        <p:spPr>
-          <a:xfrm>
-            <a:off x="6492240" y="2514600"/>
-            <a:ext cx="5212080" cy="1508760"/>
-          </a:xfrm>
-          <a:prstGeom prst="rect">
-            <a:avLst/>
-          </a:prstGeom>
-          <a:solidFill>
-            <a:srgbClr val="1E293B"/>
-          </a:solidFill>
-          <a:ln w="9525">
-            <a:solidFill>
-              <a:srgbClr val="334155"/>
-            </a:solidFill>
-          </a:ln>
-          <a:effectLst/>
-        </p:spPr>
-        <p:style>
-          <a:lnRef idx="1">
-            <a:schemeClr val="accent1"/>
-          </a:lnRef>
-          <a:fillRef idx="3">
-            <a:schemeClr val="accent1"/>
-          </a:fillRef>
-          <a:effectRef idx="2">
-            <a:schemeClr val="accent1"/>
-          </a:effectRef>
-          <a:fontRef idx="minor">
-            <a:schemeClr val="lt1"/>
-          </a:fontRef>
-        </p:style>
-        <p:txBody>
-          <a:bodyPr rtlCol="0" anchor="ctr"/>
-          <a:lstStyle/>
-          <a:p>
-            <a:pPr algn="ctr"/>
-          </a:p>
-        </p:txBody>
-      </p:sp>
-      <p:sp>
-        <p:nvSpPr>
-          <p:cNvPr id="10" name="TextBox 9"/>
-          <p:cNvSpPr txBox="1"/>
-          <p:nvPr/>
-        </p:nvSpPr>
-        <p:spPr>
-          <a:xfrm>
-            <a:off x="6675120" y="2679192"/>
-            <a:ext cx="4846320" cy="320040"/>
-          </a:xfrm>
-          <a:prstGeom prst="rect">
-            <a:avLst/>
-          </a:prstGeom>
-          <a:noFill/>
-        </p:spPr>
-        <p:txBody>
-          <a:bodyPr wrap="square" lIns="0" rIns="0" tIns="0" bIns="0" anchor="t">
-            <a:spAutoFit/>
-          </a:bodyPr>
-          <a:lstStyle/>
-          <a:p>
-            <a:pPr algn="l"/>
-            <a:r>
-              <a:rPr sz="1400" b="1">
-                <a:solidFill>
-                  <a:srgbClr val="F8FAFC"/>
-                </a:solidFill>
-                <a:latin typeface="DM Sans"/>
-              </a:rPr>
-              <a:t>Azure Cloud Migration</a:t>
-            </a:r>
-          </a:p>
-        </p:txBody>
-      </p:sp>
-      <p:sp>
-        <p:nvSpPr>
-          <p:cNvPr id="11" name="TextBox 10"/>
-          <p:cNvSpPr txBox="1"/>
-          <p:nvPr/>
-        </p:nvSpPr>
-        <p:spPr>
-          <a:xfrm>
-            <a:off x="6675120" y="3063240"/>
-            <a:ext cx="4846320" cy="822960"/>
-          </a:xfrm>
-          <a:prstGeom prst="rect">
-            <a:avLst/>
-          </a:prstGeom>
-          <a:noFill/>
-        </p:spPr>
-        <p:txBody>
-          <a:bodyPr wrap="square" lIns="0" rIns="0" tIns="0" bIns="0" anchor="t">
-            <a:spAutoFit/>
-          </a:bodyPr>
-          <a:lstStyle/>
-          <a:p>
-            <a:pPr algn="l"/>
-            <a:r>
-              <a:rPr sz="1200" b="0">
-                <a:solidFill>
-                  <a:srgbClr val="94A3B8"/>
-                </a:solidFill>
-                <a:latin typeface="Inter"/>
-              </a:rPr>
-              <a:t>Led a 6-month migration to Azure as the project's main representative, among the first internal apps the bank migrated.</a:t>
-            </a:r>
-          </a:p>
-        </p:txBody>
-      </p:sp>
-      <p:sp>
-        <p:nvSpPr>
-          <p:cNvPr id="12" name="Rectangle 11"/>
-          <p:cNvSpPr/>
-          <p:nvPr/>
-        </p:nvSpPr>
-        <p:spPr>
-          <a:xfrm>
-            <a:off x="822960" y="4251960"/>
-            <a:ext cx="5212080" cy="1508760"/>
-          </a:xfrm>
-          <a:prstGeom prst="rect">
-            <a:avLst/>
-          </a:prstGeom>
-          <a:solidFill>
-            <a:srgbClr val="1E293B"/>
-          </a:solidFill>
-          <a:ln w="9525">
-            <a:solidFill>
-              <a:srgbClr val="334155"/>
-            </a:solidFill>
-          </a:ln>
-          <a:effectLst/>
-        </p:spPr>
-        <p:style>
-          <a:lnRef idx="1">
-            <a:schemeClr val="accent1"/>
-          </a:lnRef>
-          <a:fillRef idx="3">
-            <a:schemeClr val="accent1"/>
-          </a:fillRef>
-          <a:effectRef idx="2">
-            <a:schemeClr val="accent1"/>
-          </a:effectRef>
-          <a:fontRef idx="minor">
-            <a:schemeClr val="lt1"/>
-          </a:fontRef>
-        </p:style>
-        <p:txBody>
-          <a:bodyPr rtlCol="0" anchor="ctr"/>
-          <a:lstStyle/>
-          <a:p>
-            <a:pPr algn="ctr"/>
-          </a:p>
-        </p:txBody>
-      </p:sp>
-      <p:sp>
-        <p:nvSpPr>
-          <p:cNvPr id="13" name="TextBox 12"/>
-          <p:cNvSpPr txBox="1"/>
-          <p:nvPr/>
-        </p:nvSpPr>
-        <p:spPr>
-          <a:xfrm>
-            <a:off x="1005840" y="4416552"/>
-            <a:ext cx="4846320" cy="320040"/>
-          </a:xfrm>
-          <a:prstGeom prst="rect">
-            <a:avLst/>
-          </a:prstGeom>
-          <a:noFill/>
-        </p:spPr>
-        <p:txBody>
-          <a:bodyPr wrap="square" lIns="0" rIns="0" tIns="0" bIns="0" anchor="t">
-            <a:spAutoFit/>
-          </a:bodyPr>
-          <a:lstStyle/>
-          <a:p>
-            <a:pPr algn="l"/>
-            <a:r>
-              <a:rPr sz="1400" b="1">
-                <a:solidFill>
-                  <a:srgbClr val="F8FAFC"/>
-                </a:solidFill>
-                <a:latin typeface="DM Sans"/>
-              </a:rPr>
-              <a:t>Optum (current)</a:t>
-            </a:r>
-          </a:p>
-        </p:txBody>
-      </p:sp>
-      <p:sp>
-        <p:nvSpPr>
-          <p:cNvPr id="14" name="TextBox 13"/>
-          <p:cNvSpPr txBox="1"/>
-          <p:nvPr/>
-        </p:nvSpPr>
-        <p:spPr>
-          <a:xfrm>
-            <a:off x="1005840" y="4800600"/>
-            <a:ext cx="4846320" cy="822960"/>
-          </a:xfrm>
-          <a:prstGeom prst="rect">
-            <a:avLst/>
-          </a:prstGeom>
-          <a:noFill/>
-        </p:spPr>
-        <p:txBody>
-          <a:bodyPr wrap="square" lIns="0" rIns="0" tIns="0" bIns="0" anchor="t">
-            <a:spAutoFit/>
-          </a:bodyPr>
-          <a:lstStyle/>
-          <a:p>
-            <a:pPr algn="l"/>
-            <a:r>
-              <a:rPr sz="1200" b="0">
-                <a:solidFill>
-                  <a:srgbClr val="94A3B8"/>
-                </a:solidFill>
-                <a:latin typeface="Inter"/>
-              </a:rPr>
-              <a:t>Angular + .NET + PostgreSQL on a large Agile team. 150+ story points delivered. Team's go-to for AI-assisted development. Contract won April 2026.</a:t>
-            </a:r>
-          </a:p>
-        </p:txBody>
-      </p:sp>
-      <p:sp>
-        <p:nvSpPr>
-          <p:cNvPr id="15" name="Rectangle 14"/>
-          <p:cNvSpPr/>
-          <p:nvPr/>
-        </p:nvSpPr>
-        <p:spPr>
-          <a:xfrm>
-            <a:off x="6492240" y="4251960"/>
-            <a:ext cx="5212080" cy="1508760"/>
-          </a:xfrm>
-          <a:prstGeom prst="rect">
-            <a:avLst/>
-          </a:prstGeom>
-          <a:solidFill>
-            <a:srgbClr val="1E293B"/>
-          </a:solidFill>
-          <a:ln w="9525">
-            <a:solidFill>
-              <a:srgbClr val="334155"/>
-            </a:solidFill>
-          </a:ln>
-          <a:effectLst/>
-        </p:spPr>
-        <p:style>
-          <a:lnRef idx="1">
-            <a:schemeClr val="accent1"/>
-          </a:lnRef>
-          <a:fillRef idx="3">
-            <a:schemeClr val="accent1"/>
-          </a:fillRef>
-          <a:effectRef idx="2">
-            <a:schemeClr val="accent1"/>
-          </a:effectRef>
-          <a:fontRef idx="minor">
-            <a:schemeClr val="lt1"/>
-          </a:fontRef>
-        </p:style>
-        <p:txBody>
-          <a:bodyPr rtlCol="0" anchor="ctr"/>
-          <a:lstStyle/>
-          <a:p>
-            <a:pPr algn="ctr"/>
-          </a:p>
-        </p:txBody>
-      </p:sp>
-      <p:sp>
-        <p:nvSpPr>
-          <p:cNvPr id="16" name="TextBox 15"/>
-          <p:cNvSpPr txBox="1"/>
-          <p:nvPr/>
-        </p:nvSpPr>
-        <p:spPr>
-          <a:xfrm>
-            <a:off x="6675120" y="4416552"/>
-            <a:ext cx="4846320" cy="320040"/>
-          </a:xfrm>
-          <a:prstGeom prst="rect">
-            <a:avLst/>
-          </a:prstGeom>
-          <a:noFill/>
-        </p:spPr>
-        <p:txBody>
-          <a:bodyPr wrap="square" lIns="0" rIns="0" tIns="0" bIns="0" anchor="t">
-            <a:spAutoFit/>
-          </a:bodyPr>
-          <a:lstStyle/>
-          <a:p>
-            <a:pPr algn="l"/>
-            <a:r>
-              <a:rPr sz="1400" b="1">
-                <a:solidFill>
-                  <a:srgbClr val="F8FAFC"/>
-                </a:solidFill>
-                <a:latin typeface="DM Sans"/>
-              </a:rPr>
-              <a:t>AI delivery, daily</a:t>
-            </a:r>
-          </a:p>
-        </p:txBody>
-      </p:sp>
-      <p:sp>
-        <p:nvSpPr>
-          <p:cNvPr id="17" name="TextBox 16"/>
-          <p:cNvSpPr txBox="1"/>
-          <p:nvPr/>
-        </p:nvSpPr>
-        <p:spPr>
-          <a:xfrm>
-            <a:off x="6675120" y="4800600"/>
-            <a:ext cx="4846320" cy="822960"/>
-          </a:xfrm>
-          <a:prstGeom prst="rect">
-            <a:avLst/>
-          </a:prstGeom>
-          <a:noFill/>
-        </p:spPr>
-        <p:txBody>
-          <a:bodyPr wrap="square" lIns="0" rIns="0" tIns="0" bIns="0" anchor="t">
-            <a:spAutoFit/>
-          </a:bodyPr>
-          <a:lstStyle/>
-          <a:p>
-            <a:pPr algn="l"/>
-            <a:r>
-              <a:rPr sz="1200" b="0">
-                <a:solidFill>
-                  <a:srgbClr val="94A3B8"/>
-                </a:solidFill>
-                <a:latin typeface="Inter"/>
-              </a:rPr>
-              <a:t>Built this demo's in-browser RAG chatbot in a single session using Transformers.js, the same stack I would use on your production build.</a:t>
-            </a:r>
-          </a:p>
-        </p:txBody>
-      </p:sp>
-      <p:sp>
-        <p:nvSpPr>
-          <p:cNvPr id="18" name="TextBox 17"/>
-          <p:cNvSpPr txBox="1"/>
-          <p:nvPr/>
-        </p:nvSpPr>
-        <p:spPr>
-          <a:xfrm>
-            <a:off x="457200" y="6492240"/>
-            <a:ext cx="8229600" cy="256032"/>
-          </a:xfrm>
-          <a:prstGeom prst="rect">
-            <a:avLst/>
-          </a:prstGeom>
-          <a:noFill/>
-        </p:spPr>
-        <p:txBody>
-          <a:bodyPr wrap="square" lIns="0" rIns="0" tIns="0" bIns="0" anchor="t">
-            <a:spAutoFit/>
-          </a:bodyPr>
-          <a:lstStyle/>
-          <a:p>
-            <a:pPr algn="l"/>
-            <a:r>
-              <a:rPr sz="850" b="0">
-                <a:solidFill>
-                  <a:srgbClr val="94A3B8"/>
-                </a:solidFill>
-                <a:latin typeface="Inter"/>
-              </a:rPr>
-              <a:t>MICHAEL WEGTER  /  AI CUSTOMER SUPPORT CHATBOT  /  PROPOSAL</a:t>
-            </a:r>
-          </a:p>
-        </p:txBody>
-      </p:sp>
-      <p:sp>
-        <p:nvSpPr>
-          <p:cNvPr id="19" name="TextBox 18"/>
-          <p:cNvSpPr txBox="1"/>
-          <p:nvPr/>
-        </p:nvSpPr>
-        <p:spPr>
-          <a:xfrm>
-            <a:off x="11155680" y="6492240"/>
-            <a:ext cx="914400" cy="256032"/>
-          </a:xfrm>
-          <a:prstGeom prst="rect">
-            <a:avLst/>
-          </a:prstGeom>
-          <a:noFill/>
-        </p:spPr>
-        <p:txBody>
-          <a:bodyPr wrap="square" lIns="0" rIns="0" tIns="0" bIns="0" anchor="t">
-            <a:spAutoFit/>
-          </a:bodyPr>
-          <a:lstStyle/>
-          <a:p>
-            <a:pPr algn="r"/>
-            <a:r>
-              <a:rPr sz="850" b="0">
-                <a:solidFill>
-                  <a:srgbClr val="94A3B8"/>
-                </a:solidFill>
-                <a:latin typeface="Inter"/>
-              </a:rPr>
-              <a:t>8 / 9</a:t>
-            </a:r>
-          </a:p>
-        </p:txBody>
-      </p:sp>
-    </p:spTree>
-  </p:cSld>
-  <p:clrMapOvr>
-    <a:masterClrMapping/>
-  </p:clrMapOvr>
-</p:sld>
-</file>
-
-<file path=ppt/slides/slide9.xml><?xml version="1.0" encoding="utf-8"?>
-<p:sld xmlns:a="http://schemas.openxmlformats.org/drawingml/2006/main" xmlns:p="http://schemas.openxmlformats.org/presentationml/2006/main" xmlns:r="http://schemas.openxmlformats.org/officeDocument/2006/relationships">
-  <p:cSld>
-    <p:spTree>
-      <p:nvGrpSpPr>
-        <p:cNvPr id="1" name=""/>
-        <p:cNvGrpSpPr/>
-        <p:nvPr/>
-      </p:nvGrpSpPr>
-      <p:grpSpPr/>
-      <p:sp>
-        <p:nvSpPr>
-          <p:cNvPr id="2" name="Rectangle 1"/>
-          <p:cNvSpPr/>
-          <p:nvPr/>
-        </p:nvSpPr>
-        <p:spPr>
-          <a:xfrm>
-            <a:off x="0" y="0"/>
-            <a:ext cx="12191695" cy="6858000"/>
-          </a:xfrm>
-          <a:prstGeom prst="rect">
-            <a:avLst/>
-          </a:prstGeom>
-          <a:solidFill>
-            <a:srgbClr val="0F172A"/>
-          </a:solidFill>
-          <a:ln>
-            <a:noFill/>
-          </a:ln>
-          <a:effectLst/>
-        </p:spPr>
-        <p:style>
-          <a:lnRef idx="1">
-            <a:schemeClr val="accent1"/>
-          </a:lnRef>
-          <a:fillRef idx="3">
-            <a:schemeClr val="accent1"/>
-          </a:fillRef>
-          <a:effectRef idx="2">
-            <a:schemeClr val="accent1"/>
-          </a:effectRef>
-          <a:fontRef idx="minor">
-            <a:schemeClr val="lt1"/>
-          </a:fontRef>
-        </p:style>
-        <p:txBody>
-          <a:bodyPr rtlCol="0" anchor="ctr"/>
-          <a:lstStyle/>
-          <a:p>
-            <a:pPr algn="ctr"/>
+            <a:endParaRPr/>
           </a:p>
         </p:txBody>
       </p:sp>
@@ -9799,6 +8643,7 @@
           <a:lstStyle/>
           <a:p>
             <a:pPr algn="ctr"/>
+            <a:endParaRPr/>
           </a:p>
         </p:txBody>
       </p:sp>
@@ -9843,6 +8688,7 @@
           <a:lstStyle/>
           <a:p>
             <a:pPr algn="ctr"/>
+            <a:endParaRPr/>
           </a:p>
         </p:txBody>
       </p:sp>
@@ -9887,6 +8733,7 @@
           <a:lstStyle/>
           <a:p>
             <a:pPr algn="ctr"/>
+            <a:endParaRPr/>
           </a:p>
         </p:txBody>
       </p:sp>
@@ -9907,7 +8754,7 @@
           <a:noFill/>
         </p:spPr>
         <p:txBody>
-          <a:bodyPr wrap="square" lIns="0" rIns="0" tIns="0" bIns="0" anchor="t">
+          <a:bodyPr wrap="square" lIns="0" tIns="0" rIns="0" bIns="0" anchor="t">
             <a:spAutoFit/>
           </a:bodyPr>
           <a:lstStyle/>
@@ -9942,7 +8789,7 @@
           <a:noFill/>
         </p:spPr>
         <p:txBody>
-          <a:bodyPr wrap="square" lIns="0" rIns="0" tIns="0" bIns="0" anchor="t">
+          <a:bodyPr wrap="square" lIns="0" tIns="0" rIns="0" bIns="0" anchor="t">
             <a:spAutoFit/>
           </a:bodyPr>
           <a:lstStyle/>
@@ -9977,7 +8824,7 @@
           <a:noFill/>
         </p:spPr>
         <p:txBody>
-          <a:bodyPr wrap="square" lIns="0" rIns="0" tIns="0" bIns="0" anchor="t">
+          <a:bodyPr wrap="square" lIns="0" tIns="0" rIns="0" bIns="0" anchor="t">
             <a:spAutoFit/>
           </a:bodyPr>
           <a:lstStyle/>
@@ -10012,7 +8859,7 @@
           <a:noFill/>
         </p:spPr>
         <p:txBody>
-          <a:bodyPr wrap="square" lIns="0" rIns="0" tIns="0" bIns="0" anchor="t">
+          <a:bodyPr wrap="square" lIns="0" tIns="0" rIns="0" bIns="0" anchor="t">
             <a:spAutoFit/>
           </a:bodyPr>
           <a:lstStyle/>
@@ -10047,7 +8894,7 @@
           <a:noFill/>
         </p:spPr>
         <p:txBody>
-          <a:bodyPr wrap="square" lIns="0" rIns="0" tIns="0" bIns="0" anchor="t">
+          <a:bodyPr wrap="square" lIns="0" tIns="0" rIns="0" bIns="0" anchor="t">
             <a:spAutoFit/>
           </a:bodyPr>
           <a:lstStyle/>
@@ -10082,7 +8929,7 @@
           <a:noFill/>
         </p:spPr>
         <p:txBody>
-          <a:bodyPr wrap="square" lIns="0" rIns="0" tIns="0" bIns="0" anchor="t">
+          <a:bodyPr wrap="square" lIns="0" tIns="0" rIns="0" bIns="0" anchor="t">
             <a:spAutoFit/>
           </a:bodyPr>
           <a:lstStyle/>
@@ -10117,7 +8964,7 @@
           <a:noFill/>
         </p:spPr>
         <p:txBody>
-          <a:bodyPr wrap="square" lIns="0" rIns="0" tIns="0" bIns="0" anchor="t">
+          <a:bodyPr wrap="square" lIns="0" tIns="0" rIns="0" bIns="0" anchor="t">
             <a:spAutoFit/>
           </a:bodyPr>
           <a:lstStyle/>

</xml_diff>